<commit_message>
Refactor: JSON slides + parser = contenu dissocié du contenant
- presentations/ep01-outlook.json: contenu des slides (éditable!)
- scripts/parse.py: générateur PowerPoint universel
- .venv: dépendances isolées
- generate.sh: script de convenience
</commit_message>
<xml_diff>
--- a/presentations/La_Minute_Copilot_Outlook.pptx
+++ b/presentations/La_Minute_Copilot_Outlook.pptx
@@ -3162,7 +3162,7 @@
             <a:pPr algn="ctr">
               <a:defRPr sz="2800" b="0">
                 <a:solidFill>
-                  <a:srgbClr val="CCE5FF"/>
+                  <a:srgbClr val="AAD4F0"/>
                 </a:solidFill>
                 <a:latin typeface="Calibri"/>
               </a:defRPr>
@@ -3260,7 +3260,7 @@
             <a:pPr algn="l">
               <a:defRPr sz="3200" b="1">
                 <a:solidFill>
-                  <a:srgbClr val="0078D4"/>
+                  <a:srgbClr val="2B2B2B"/>
                 </a:solidFill>
                 <a:latin typeface="Calibri"/>
               </a:defRPr>
@@ -3316,7 +3316,7 @@
         <p:spPr>
           <a:xfrm>
             <a:off x="457200" y="1554480"/>
-            <a:ext cx="3657600" cy="4572000"/>
+            <a:ext cx="3474720" cy="4754880"/>
           </a:xfrm>
           <a:prstGeom prst="rect">
             <a:avLst/>
@@ -3329,7 +3329,6 @@
               <a:srgbClr val="E0E0E0"/>
             </a:solidFill>
           </a:ln>
-          <a:effectLst/>
         </p:spPr>
         <p:style>
           <a:lnRef idx="1">
@@ -3362,7 +3361,7 @@
         <p:spPr>
           <a:xfrm>
             <a:off x="731520" y="1737360"/>
-            <a:ext cx="3108960" cy="457200"/>
+            <a:ext cx="2926079" cy="457200"/>
           </a:xfrm>
           <a:prstGeom prst="rect">
             <a:avLst/>
@@ -3398,7 +3397,7 @@
         <p:spPr>
           <a:xfrm>
             <a:off x="731520" y="2194560"/>
-            <a:ext cx="3108960" cy="3657600"/>
+            <a:ext cx="2926079" cy="3840480"/>
           </a:xfrm>
           <a:prstGeom prst="rect">
             <a:avLst/>
@@ -3413,7 +3412,7 @@
           <a:p>
             <a:pPr>
               <a:spcAft>
-                <a:spcPts val="600"/>
+                <a:spcPts val="400"/>
               </a:spcAft>
               <a:defRPr sz="1300">
                 <a:solidFill>
@@ -3429,39 +3428,23 @@
           <a:p>
             <a:pPr>
               <a:spcAft>
-                <a:spcPts val="600"/>
-              </a:spcAft>
-              <a:defRPr sz="1300">
-                <a:solidFill>
-                  <a:srgbClr val="2B2B2B"/>
-                </a:solidFill>
-                <a:latin typeface="Calibri"/>
-              </a:defRPr>
-            </a:pPr>
-            <a:r>
-              <a:t>2. Cliquer sur l'icône Copilot</a:t>
-            </a:r>
-          </a:p>
-          <a:p>
-            <a:pPr>
-              <a:spcAft>
-                <a:spcPts val="600"/>
-              </a:spcAft>
-              <a:defRPr sz="1300">
-                <a:solidFill>
-                  <a:srgbClr val="2B2B2B"/>
-                </a:solidFill>
-                <a:latin typeface="Calibri"/>
-              </a:defRPr>
-            </a:pPr>
-            <a:r>
-              <a:t>dans le ruban</a:t>
-            </a:r>
-          </a:p>
-          <a:p>
-            <a:pPr>
-              <a:spcAft>
-                <a:spcPts val="600"/>
+                <a:spcPts val="400"/>
+              </a:spcAft>
+              <a:defRPr sz="1300">
+                <a:solidFill>
+                  <a:srgbClr val="2B2B2B"/>
+                </a:solidFill>
+                <a:latin typeface="Calibri"/>
+              </a:defRPr>
+            </a:pPr>
+            <a:r>
+              <a:t>2. Cliquer sur l'icône Copilot dans le ruban</a:t>
+            </a:r>
+          </a:p>
+          <a:p>
+            <a:pPr>
+              <a:spcAft>
+                <a:spcPts val="400"/>
               </a:spcAft>
               <a:defRPr sz="1300">
                 <a:solidFill>
@@ -3477,20 +3460,20 @@
           <a:p>
             <a:pPr>
               <a:spcAft>
-                <a:spcPts val="600"/>
-              </a:spcAft>
-              <a:defRPr sz="1300">
-                <a:solidFill>
-                  <a:srgbClr val="2B2B2B"/>
-                </a:solidFill>
-                <a:latin typeface="Calibri"/>
-              </a:defRPr>
-            </a:pPr>
-          </a:p>
-          <a:p>
-            <a:pPr>
-              <a:spcAft>
-                <a:spcPts val="600"/>
+                <a:spcPts val="400"/>
+              </a:spcAft>
+              <a:defRPr sz="1300">
+                <a:solidFill>
+                  <a:srgbClr val="2B2B2B"/>
+                </a:solidFill>
+                <a:latin typeface="Calibri"/>
+              </a:defRPr>
+            </a:pPr>
+          </a:p>
+          <a:p>
+            <a:pPr>
+              <a:spcAft>
+                <a:spcPts val="400"/>
               </a:spcAft>
               <a:defRPr sz="1300">
                 <a:solidFill>
@@ -3506,7 +3489,7 @@
           <a:p>
             <a:pPr>
               <a:spcAft>
-                <a:spcPts val="600"/>
+                <a:spcPts val="400"/>
               </a:spcAft>
               <a:defRPr sz="1300">
                 <a:solidFill>
@@ -3530,7 +3513,7 @@
         <p:spPr>
           <a:xfrm>
             <a:off x="4297680" y="1554480"/>
-            <a:ext cx="3657600" cy="4572000"/>
+            <a:ext cx="3474720" cy="4754880"/>
           </a:xfrm>
           <a:prstGeom prst="rect">
             <a:avLst/>
@@ -3543,7 +3526,6 @@
               <a:srgbClr val="E0E0E0"/>
             </a:solidFill>
           </a:ln>
-          <a:effectLst/>
         </p:spPr>
         <p:style>
           <a:lnRef idx="1">
@@ -3576,7 +3558,7 @@
         <p:spPr>
           <a:xfrm>
             <a:off x="4572000" y="1737360"/>
-            <a:ext cx="3108960" cy="457200"/>
+            <a:ext cx="2926079" cy="457200"/>
           </a:xfrm>
           <a:prstGeom prst="rect">
             <a:avLst/>
@@ -3612,7 +3594,7 @@
         <p:spPr>
           <a:xfrm>
             <a:off x="4572000" y="2194560"/>
-            <a:ext cx="3108960" cy="3657600"/>
+            <a:ext cx="2926079" cy="3840480"/>
           </a:xfrm>
           <a:prstGeom prst="rect">
             <a:avLst/>
@@ -3627,52 +3609,52 @@
           <a:p>
             <a:pPr>
               <a:spcAft>
-                <a:spcPts val="600"/>
-              </a:spcAft>
-              <a:defRPr sz="1300">
-                <a:solidFill>
-                  <a:srgbClr val="2B2B2B"/>
-                </a:solidFill>
-                <a:latin typeface="Calibri"/>
-              </a:defRPr>
-            </a:pPr>
-            <a:r>
-              <a:t>«Résume ce fil de discussion</a:t>
-            </a:r>
-          </a:p>
-          <a:p>
-            <a:pPr>
-              <a:spcAft>
-                <a:spcPts val="600"/>
-              </a:spcAft>
-              <a:defRPr sz="1300">
-                <a:solidFill>
-                  <a:srgbClr val="2B2B2B"/>
-                </a:solidFill>
-                <a:latin typeface="Calibri"/>
-              </a:defRPr>
-            </a:pPr>
-            <a:r>
-              <a:t>et liste les décisions prises»</a:t>
-            </a:r>
-          </a:p>
-          <a:p>
-            <a:pPr>
-              <a:spcAft>
-                <a:spcPts val="600"/>
-              </a:spcAft>
-              <a:defRPr sz="1300">
-                <a:solidFill>
-                  <a:srgbClr val="2B2B2B"/>
-                </a:solidFill>
-                <a:latin typeface="Calibri"/>
-              </a:defRPr>
-            </a:pPr>
-          </a:p>
-          <a:p>
-            <a:pPr>
-              <a:spcAft>
-                <a:spcPts val="600"/>
+                <a:spcPts val="400"/>
+              </a:spcAft>
+              <a:defRPr sz="1300">
+                <a:solidFill>
+                  <a:srgbClr val="2B2B2B"/>
+                </a:solidFill>
+                <a:latin typeface="Calibri"/>
+              </a:defRPr>
+            </a:pPr>
+            <a:r>
+              <a:t>«Résume ce fil de discussion et</a:t>
+            </a:r>
+          </a:p>
+          <a:p>
+            <a:pPr>
+              <a:spcAft>
+                <a:spcPts val="400"/>
+              </a:spcAft>
+              <a:defRPr sz="1300">
+                <a:solidFill>
+                  <a:srgbClr val="2B2B2B"/>
+                </a:solidFill>
+                <a:latin typeface="Calibri"/>
+              </a:defRPr>
+            </a:pPr>
+            <a:r>
+              <a:t>liste les décisions prises»</a:t>
+            </a:r>
+          </a:p>
+          <a:p>
+            <a:pPr>
+              <a:spcAft>
+                <a:spcPts val="400"/>
+              </a:spcAft>
+              <a:defRPr sz="1300">
+                <a:solidFill>
+                  <a:srgbClr val="2B2B2B"/>
+                </a:solidFill>
+                <a:latin typeface="Calibri"/>
+              </a:defRPr>
+            </a:pPr>
+          </a:p>
+          <a:p>
+            <a:pPr>
+              <a:spcAft>
+                <a:spcPts val="400"/>
               </a:spcAft>
               <a:defRPr sz="1300">
                 <a:solidFill>
@@ -3688,7 +3670,7 @@
           <a:p>
             <a:pPr>
               <a:spcAft>
-                <a:spcPts val="600"/>
+                <a:spcPts val="400"/>
               </a:spcAft>
               <a:defRPr sz="1300">
                 <a:solidFill>
@@ -3704,62 +3686,46 @@
           <a:p>
             <a:pPr>
               <a:spcAft>
-                <a:spcPts val="600"/>
-              </a:spcAft>
-              <a:defRPr sz="1300">
-                <a:solidFill>
-                  <a:srgbClr val="2B2B2B"/>
-                </a:solidFill>
-                <a:latin typeface="Calibri"/>
-              </a:defRPr>
-            </a:pPr>
-          </a:p>
-          <a:p>
-            <a:pPr>
-              <a:spcAft>
-                <a:spcPts val="600"/>
-              </a:spcAft>
-              <a:defRPr sz="1300">
-                <a:solidFill>
-                  <a:srgbClr val="2B2B2B"/>
-                </a:solidFill>
-                <a:latin typeface="Calibri"/>
-              </a:defRPr>
-            </a:pPr>
-            <a:r>
-              <a:t>«Extrais les action items</a:t>
-            </a:r>
-          </a:p>
-          <a:p>
-            <a:pPr>
-              <a:spcAft>
-                <a:spcPts val="600"/>
-              </a:spcAft>
-              <a:defRPr sz="1300">
-                <a:solidFill>
-                  <a:srgbClr val="2B2B2B"/>
-                </a:solidFill>
-                <a:latin typeface="Calibri"/>
-              </a:defRPr>
-            </a:pPr>
-            <a:r>
-              <a:t>avec responsables et</a:t>
-            </a:r>
-          </a:p>
-          <a:p>
-            <a:pPr>
-              <a:spcAft>
-                <a:spcPts val="600"/>
-              </a:spcAft>
-              <a:defRPr sz="1300">
-                <a:solidFill>
-                  <a:srgbClr val="2B2B2B"/>
-                </a:solidFill>
-                <a:latin typeface="Calibri"/>
-              </a:defRPr>
-            </a:pPr>
-            <a:r>
-              <a:t>échéances»</a:t>
+                <a:spcPts val="400"/>
+              </a:spcAft>
+              <a:defRPr sz="1300">
+                <a:solidFill>
+                  <a:srgbClr val="2B2B2B"/>
+                </a:solidFill>
+                <a:latin typeface="Calibri"/>
+              </a:defRPr>
+            </a:pPr>
+          </a:p>
+          <a:p>
+            <a:pPr>
+              <a:spcAft>
+                <a:spcPts val="400"/>
+              </a:spcAft>
+              <a:defRPr sz="1300">
+                <a:solidFill>
+                  <a:srgbClr val="2B2B2B"/>
+                </a:solidFill>
+                <a:latin typeface="Calibri"/>
+              </a:defRPr>
+            </a:pPr>
+            <a:r>
+              <a:t>«Extrais les action items avec</a:t>
+            </a:r>
+          </a:p>
+          <a:p>
+            <a:pPr>
+              <a:spcAft>
+                <a:spcPts val="400"/>
+              </a:spcAft>
+              <a:defRPr sz="1300">
+                <a:solidFill>
+                  <a:srgbClr val="2B2B2B"/>
+                </a:solidFill>
+                <a:latin typeface="Calibri"/>
+              </a:defRPr>
+            </a:pPr>
+            <a:r>
+              <a:t>responsables et échéances»</a:t>
             </a:r>
           </a:p>
         </p:txBody>
@@ -3773,7 +3739,7 @@
         <p:spPr>
           <a:xfrm>
             <a:off x="8138160" y="1554480"/>
-            <a:ext cx="3657600" cy="4572000"/>
+            <a:ext cx="3474720" cy="4754880"/>
           </a:xfrm>
           <a:prstGeom prst="rect">
             <a:avLst/>
@@ -3786,7 +3752,6 @@
               <a:srgbClr val="E0E0E0"/>
             </a:solidFill>
           </a:ln>
-          <a:effectLst/>
         </p:spPr>
         <p:style>
           <a:lnRef idx="1">
@@ -3819,7 +3784,7 @@
         <p:spPr>
           <a:xfrm>
             <a:off x="8412480" y="1737360"/>
-            <a:ext cx="3108960" cy="457200"/>
+            <a:ext cx="2926079" cy="457200"/>
           </a:xfrm>
           <a:prstGeom prst="rect">
             <a:avLst/>
@@ -3855,7 +3820,7 @@
         <p:spPr>
           <a:xfrm>
             <a:off x="8412480" y="2194560"/>
-            <a:ext cx="3108960" cy="3657600"/>
+            <a:ext cx="2926079" cy="3840480"/>
           </a:xfrm>
           <a:prstGeom prst="rect">
             <a:avLst/>
@@ -3870,7 +3835,7 @@
           <a:p>
             <a:pPr>
               <a:spcAft>
-                <a:spcPts val="600"/>
+                <a:spcPts val="400"/>
               </a:spcAft>
               <a:defRPr sz="1300">
                 <a:solidFill>
@@ -3886,7 +3851,7 @@
           <a:p>
             <a:pPr>
               <a:spcAft>
-                <a:spcPts val="600"/>
+                <a:spcPts val="400"/>
               </a:spcAft>
               <a:defRPr sz="1300">
                 <a:solidFill>
@@ -3902,20 +3867,20 @@
           <a:p>
             <a:pPr>
               <a:spcAft>
-                <a:spcPts val="600"/>
-              </a:spcAft>
-              <a:defRPr sz="1300">
-                <a:solidFill>
-                  <a:srgbClr val="2B2B2B"/>
-                </a:solidFill>
-                <a:latin typeface="Calibri"/>
-              </a:defRPr>
-            </a:pPr>
-          </a:p>
-          <a:p>
-            <a:pPr>
-              <a:spcAft>
-                <a:spcPts val="600"/>
+                <a:spcPts val="400"/>
+              </a:spcAft>
+              <a:defRPr sz="1300">
+                <a:solidFill>
+                  <a:srgbClr val="2B2B2B"/>
+                </a:solidFill>
+                <a:latin typeface="Calibri"/>
+              </a:defRPr>
+            </a:pPr>
+          </a:p>
+          <a:p>
+            <a:pPr>
+              <a:spcAft>
+                <a:spcPts val="400"/>
               </a:spcAft>
               <a:defRPr sz="1300">
                 <a:solidFill>
@@ -3931,7 +3896,7 @@
           <a:p>
             <a:pPr>
               <a:spcAft>
-                <a:spcPts val="600"/>
+                <a:spcPts val="400"/>
               </a:spcAft>
               <a:defRPr sz="1300">
                 <a:solidFill>
@@ -3947,7 +3912,7 @@
           <a:p>
             <a:pPr>
               <a:spcAft>
-                <a:spcPts val="600"/>
+                <a:spcPts val="400"/>
               </a:spcAft>
               <a:defRPr sz="1300">
                 <a:solidFill>
@@ -3963,20 +3928,20 @@
           <a:p>
             <a:pPr>
               <a:spcAft>
-                <a:spcPts val="600"/>
-              </a:spcAft>
-              <a:defRPr sz="1300">
-                <a:solidFill>
-                  <a:srgbClr val="2B2B2B"/>
-                </a:solidFill>
-                <a:latin typeface="Calibri"/>
-              </a:defRPr>
-            </a:pPr>
-          </a:p>
-          <a:p>
-            <a:pPr>
-              <a:spcAft>
-                <a:spcPts val="600"/>
+                <a:spcPts val="400"/>
+              </a:spcAft>
+              <a:defRPr sz="1300">
+                <a:solidFill>
+                  <a:srgbClr val="2B2B2B"/>
+                </a:solidFill>
+                <a:latin typeface="Calibri"/>
+              </a:defRPr>
+            </a:pPr>
+          </a:p>
+          <a:p>
+            <a:pPr>
+              <a:spcAft>
+                <a:spcPts val="400"/>
               </a:spcAft>
               <a:defRPr sz="1300">
                 <a:solidFill>
@@ -3992,7 +3957,7 @@
           <a:p>
             <a:pPr>
               <a:spcAft>
-                <a:spcPts val="600"/>
+                <a:spcPts val="400"/>
               </a:spcAft>
               <a:defRPr sz="1300">
                 <a:solidFill>
@@ -4058,7 +4023,7 @@
             <a:pPr algn="l">
               <a:defRPr sz="3200" b="1">
                 <a:solidFill>
-                  <a:srgbClr val="0078D4"/>
+                  <a:srgbClr val="2B2B2B"/>
                 </a:solidFill>
                 <a:latin typeface="Calibri"/>
               </a:defRPr>
@@ -4114,7 +4079,7 @@
         <p:spPr>
           <a:xfrm>
             <a:off x="457200" y="1554480"/>
-            <a:ext cx="5486400" cy="4572000"/>
+            <a:ext cx="5303520" cy="4754880"/>
           </a:xfrm>
           <a:prstGeom prst="rect">
             <a:avLst/>
@@ -4127,7 +4092,6 @@
               <a:srgbClr val="E0E0E0"/>
             </a:solidFill>
           </a:ln>
-          <a:effectLst/>
         </p:spPr>
         <p:style>
           <a:lnRef idx="1">
@@ -4160,7 +4124,7 @@
         <p:spPr>
           <a:xfrm>
             <a:off x="731520" y="1737360"/>
-            <a:ext cx="4937760" cy="457200"/>
+            <a:ext cx="4754880" cy="457200"/>
           </a:xfrm>
           <a:prstGeom prst="rect">
             <a:avLst/>
@@ -4196,7 +4160,7 @@
         <p:spPr>
           <a:xfrm>
             <a:off x="731520" y="2194560"/>
-            <a:ext cx="4937760" cy="3657600"/>
+            <a:ext cx="4754880" cy="3840480"/>
           </a:xfrm>
           <a:prstGeom prst="rect">
             <a:avLst/>
@@ -4211,7 +4175,7 @@
           <a:p>
             <a:pPr>
               <a:spcAft>
-                <a:spcPts val="600"/>
+                <a:spcPts val="400"/>
               </a:spcAft>
               <a:defRPr sz="1300">
                 <a:solidFill>
@@ -4227,36 +4191,52 @@
           <a:p>
             <a:pPr>
               <a:spcAft>
-                <a:spcPts val="600"/>
-              </a:spcAft>
-              <a:defRPr sz="1300">
-                <a:solidFill>
-                  <a:srgbClr val="2B2B2B"/>
-                </a:solidFill>
-                <a:latin typeface="Calibri"/>
-              </a:defRPr>
-            </a:pPr>
-            <a:r>
-              <a:t>2. Dans le bas de la fenêtre, cliquez sur l'icône Copilot</a:t>
-            </a:r>
-          </a:p>
-          <a:p>
-            <a:pPr>
-              <a:spcAft>
-                <a:spcPts val="600"/>
-              </a:spcAft>
-              <a:defRPr sz="1300">
-                <a:solidFill>
-                  <a:srgbClr val="2B2B2B"/>
-                </a:solidFill>
-                <a:latin typeface="Calibri"/>
-              </a:defRPr>
-            </a:pPr>
-          </a:p>
-          <a:p>
-            <a:pPr>
-              <a:spcAft>
-                <a:spcPts val="600"/>
+                <a:spcPts val="400"/>
+              </a:spcAft>
+              <a:defRPr sz="1300">
+                <a:solidFill>
+                  <a:srgbClr val="2B2B2B"/>
+                </a:solidFill>
+                <a:latin typeface="Calibri"/>
+              </a:defRPr>
+            </a:pPr>
+            <a:r>
+              <a:t>2. Dans le bas de la fenêtre, cliquez</a:t>
+            </a:r>
+          </a:p>
+          <a:p>
+            <a:pPr>
+              <a:spcAft>
+                <a:spcPts val="400"/>
+              </a:spcAft>
+              <a:defRPr sz="1300">
+                <a:solidFill>
+                  <a:srgbClr val="2B2B2B"/>
+                </a:solidFill>
+                <a:latin typeface="Calibri"/>
+              </a:defRPr>
+            </a:pPr>
+            <a:r>
+              <a:t>   sur l'icône Copilot</a:t>
+            </a:r>
+          </a:p>
+          <a:p>
+            <a:pPr>
+              <a:spcAft>
+                <a:spcPts val="400"/>
+              </a:spcAft>
+              <a:defRPr sz="1300">
+                <a:solidFill>
+                  <a:srgbClr val="2B2B2B"/>
+                </a:solidFill>
+                <a:latin typeface="Calibri"/>
+              </a:defRPr>
+            </a:pPr>
+          </a:p>
+          <a:p>
+            <a:pPr>
+              <a:spcAft>
+                <a:spcPts val="400"/>
               </a:spcAft>
               <a:defRPr sz="1300">
                 <a:solidFill>
@@ -4272,23 +4252,23 @@
           <a:p>
             <a:pPr>
               <a:spcAft>
-                <a:spcPts val="600"/>
-              </a:spcAft>
-              <a:defRPr sz="1300">
-                <a:solidFill>
-                  <a:srgbClr val="2B2B2B"/>
-                </a:solidFill>
-                <a:latin typeface="Calibri"/>
-              </a:defRPr>
-            </a:pPr>
-            <a:r>
-              <a:t>«Remercie Jean et confirme que le</a:t>
-            </a:r>
-          </a:p>
-          <a:p>
-            <a:pPr>
-              <a:spcAft>
-                <a:spcPts val="600"/>
+                <a:spcPts val="400"/>
+              </a:spcAft>
+              <a:defRPr sz="1300">
+                <a:solidFill>
+                  <a:srgbClr val="2B2B2B"/>
+                </a:solidFill>
+                <a:latin typeface="Calibri"/>
+              </a:defRPr>
+            </a:pPr>
+            <a:r>
+              <a:t>   «Remercie Jean et confirme que le</a:t>
+            </a:r>
+          </a:p>
+          <a:p>
+            <a:pPr>
+              <a:spcAft>
+                <a:spcPts val="400"/>
               </a:spcAft>
               <a:defRPr sz="1300">
                 <a:solidFill>
@@ -4304,20 +4284,20 @@
           <a:p>
             <a:pPr>
               <a:spcAft>
-                <a:spcPts val="600"/>
-              </a:spcAft>
-              <a:defRPr sz="1300">
-                <a:solidFill>
-                  <a:srgbClr val="2B2B2B"/>
-                </a:solidFill>
-                <a:latin typeface="Calibri"/>
-              </a:defRPr>
-            </a:pPr>
-          </a:p>
-          <a:p>
-            <a:pPr>
-              <a:spcAft>
-                <a:spcPts val="600"/>
+                <a:spcPts val="400"/>
+              </a:spcAft>
+              <a:defRPr sz="1300">
+                <a:solidFill>
+                  <a:srgbClr val="2B2B2B"/>
+                </a:solidFill>
+                <a:latin typeface="Calibri"/>
+              </a:defRPr>
+            </a:pPr>
+          </a:p>
+          <a:p>
+            <a:pPr>
+              <a:spcAft>
+                <a:spcPts val="400"/>
               </a:spcAft>
               <a:defRPr sz="1300">
                 <a:solidFill>
@@ -4333,7 +4313,7 @@
           <a:p>
             <a:pPr>
               <a:spcAft>
-                <a:spcPts val="600"/>
+                <a:spcPts val="400"/>
               </a:spcAft>
               <a:defRPr sz="1300">
                 <a:solidFill>
@@ -4357,7 +4337,7 @@
         <p:spPr>
           <a:xfrm>
             <a:off x="6126480" y="1554480"/>
-            <a:ext cx="5486400" cy="4572000"/>
+            <a:ext cx="5303520" cy="4754880"/>
           </a:xfrm>
           <a:prstGeom prst="rect">
             <a:avLst/>
@@ -4370,7 +4350,6 @@
               <a:srgbClr val="E0E0E0"/>
             </a:solidFill>
           </a:ln>
-          <a:effectLst/>
         </p:spPr>
         <p:style>
           <a:lnRef idx="1">
@@ -4403,7 +4382,7 @@
         <p:spPr>
           <a:xfrm>
             <a:off x="6400800" y="1737360"/>
-            <a:ext cx="4937760" cy="457200"/>
+            <a:ext cx="4754880" cy="457200"/>
           </a:xfrm>
           <a:prstGeom prst="rect">
             <a:avLst/>
@@ -4425,7 +4404,7 @@
               </a:defRPr>
             </a:pPr>
             <a:r>
-              <a:t>🎨 💡 Ajustement de ton (très pratique!)</a:t>
+              <a:t>🎨 💡 Ajustement de ton</a:t>
             </a:r>
           </a:p>
         </p:txBody>
@@ -4439,7 +4418,7 @@
         <p:spPr>
           <a:xfrm>
             <a:off x="6400800" y="2194560"/>
-            <a:ext cx="4937760" cy="3657600"/>
+            <a:ext cx="4754880" cy="3840480"/>
           </a:xfrm>
           <a:prstGeom prst="rect">
             <a:avLst/>
@@ -4454,52 +4433,36 @@
           <a:p>
             <a:pPr>
               <a:spcAft>
-                <a:spcPts val="600"/>
-              </a:spcAft>
-              <a:defRPr sz="1300">
-                <a:solidFill>
-                  <a:srgbClr val="2B2B2B"/>
-                </a:solidFill>
-                <a:latin typeface="Calibri"/>
-              </a:defRPr>
-            </a:pPr>
-            <a:r>
-              <a:t>Après la génération, vous pouvez</a:t>
-            </a:r>
-          </a:p>
-          <a:p>
-            <a:pPr>
-              <a:spcAft>
-                <a:spcPts val="600"/>
-              </a:spcAft>
-              <a:defRPr sz="1300">
-                <a:solidFill>
-                  <a:srgbClr val="2B2B2B"/>
-                </a:solidFill>
-                <a:latin typeface="Calibri"/>
-              </a:defRPr>
-            </a:pPr>
-            <a:r>
-              <a:t>lui demander:</a:t>
-            </a:r>
-          </a:p>
-          <a:p>
-            <a:pPr>
-              <a:spcAft>
-                <a:spcPts val="600"/>
-              </a:spcAft>
-              <a:defRPr sz="1300">
-                <a:solidFill>
-                  <a:srgbClr val="2B2B2B"/>
-                </a:solidFill>
-                <a:latin typeface="Calibri"/>
-              </a:defRPr>
-            </a:pPr>
-          </a:p>
-          <a:p>
-            <a:pPr>
-              <a:spcAft>
-                <a:spcPts val="600"/>
+                <a:spcPts val="400"/>
+              </a:spcAft>
+              <a:defRPr sz="1300">
+                <a:solidFill>
+                  <a:srgbClr val="2B2B2B"/>
+                </a:solidFill>
+                <a:latin typeface="Calibri"/>
+              </a:defRPr>
+            </a:pPr>
+            <a:r>
+              <a:t>Après la génération, demandez:</a:t>
+            </a:r>
+          </a:p>
+          <a:p>
+            <a:pPr>
+              <a:spcAft>
+                <a:spcPts val="400"/>
+              </a:spcAft>
+              <a:defRPr sz="1300">
+                <a:solidFill>
+                  <a:srgbClr val="2B2B2B"/>
+                </a:solidFill>
+                <a:latin typeface="Calibri"/>
+              </a:defRPr>
+            </a:pPr>
+          </a:p>
+          <a:p>
+            <a:pPr>
+              <a:spcAft>
+                <a:spcPts val="400"/>
               </a:spcAft>
               <a:defRPr sz="1300">
                 <a:solidFill>
@@ -4515,7 +4478,7 @@
           <a:p>
             <a:pPr>
               <a:spcAft>
-                <a:spcPts val="600"/>
+                <a:spcPts val="400"/>
               </a:spcAft>
               <a:defRPr sz="1300">
                 <a:solidFill>
@@ -4531,7 +4494,7 @@
           <a:p>
             <a:pPr>
               <a:spcAft>
-                <a:spcPts val="600"/>
+                <a:spcPts val="400"/>
               </a:spcAft>
               <a:defRPr sz="1300">
                 <a:solidFill>
@@ -4547,7 +4510,7 @@
           <a:p>
             <a:pPr>
               <a:spcAft>
-                <a:spcPts val="600"/>
+                <a:spcPts val="400"/>
               </a:spcAft>
               <a:defRPr sz="1300">
                 <a:solidFill>
@@ -4563,7 +4526,7 @@
           <a:p>
             <a:pPr>
               <a:spcAft>
-                <a:spcPts val="600"/>
+                <a:spcPts val="400"/>
               </a:spcAft>
               <a:defRPr sz="1300">
                 <a:solidFill>
@@ -4579,36 +4542,36 @@
           <a:p>
             <a:pPr>
               <a:spcAft>
-                <a:spcPts val="600"/>
-              </a:spcAft>
-              <a:defRPr sz="1300">
-                <a:solidFill>
-                  <a:srgbClr val="2B2B2B"/>
-                </a:solidFill>
-                <a:latin typeface="Calibri"/>
-              </a:defRPr>
-            </a:pPr>
-          </a:p>
-          <a:p>
-            <a:pPr>
-              <a:spcAft>
-                <a:spcPts val="600"/>
-              </a:spcAft>
-              <a:defRPr sz="1300">
-                <a:solidFill>
-                  <a:srgbClr val="2B2B2B"/>
-                </a:solidFill>
-                <a:latin typeface="Calibri"/>
-              </a:defRPr>
-            </a:pPr>
-            <a:r>
-              <a:t>🎯 Pour qui? Tout le monde!</a:t>
-            </a:r>
-          </a:p>
-          <a:p>
-            <a:pPr>
-              <a:spcAft>
-                <a:spcPts val="600"/>
+                <a:spcPts val="400"/>
+              </a:spcAft>
+              <a:defRPr sz="1300">
+                <a:solidFill>
+                  <a:srgbClr val="2B2B2B"/>
+                </a:solidFill>
+                <a:latin typeface="Calibri"/>
+              </a:defRPr>
+            </a:pPr>
+          </a:p>
+          <a:p>
+            <a:pPr>
+              <a:spcAft>
+                <a:spcPts val="400"/>
+              </a:spcAft>
+              <a:defRPr sz="1300">
+                <a:solidFill>
+                  <a:srgbClr val="2B2B2B"/>
+                </a:solidFill>
+                <a:latin typeface="Calibri"/>
+              </a:defRPr>
+            </a:pPr>
+            <a:r>
+              <a:t>🎯 Pour tout le monde!</a:t>
+            </a:r>
+          </a:p>
+          <a:p>
+            <a:pPr>
+              <a:spcAft>
+                <a:spcPts val="400"/>
               </a:spcAft>
               <a:defRPr sz="1300">
                 <a:solidFill>
@@ -4624,7 +4587,7 @@
           <a:p>
             <a:pPr>
               <a:spcAft>
-                <a:spcPts val="600"/>
+                <a:spcPts val="400"/>
               </a:spcAft>
               <a:defRPr sz="1300">
                 <a:solidFill>
@@ -4690,7 +4653,7 @@
             <a:pPr algn="l">
               <a:defRPr sz="3200" b="1">
                 <a:solidFill>
-                  <a:srgbClr val="0078D4"/>
+                  <a:srgbClr val="2B2B2B"/>
                 </a:solidFill>
                 <a:latin typeface="Calibri"/>
               </a:defRPr>
@@ -4732,7 +4695,7 @@
               </a:defRPr>
             </a:pPr>
             <a:r>
-              <a:t>Au lieu de fouiller 50+ courriels, laissez Copilot trier pour vous</a:t>
+              <a:t>Au lieu de fouiller 50+ courriels, laissez Copilot trier</a:t>
             </a:r>
           </a:p>
         </p:txBody>
@@ -4746,7 +4709,7 @@
         <p:spPr>
           <a:xfrm>
             <a:off x="457200" y="1554480"/>
-            <a:ext cx="3657600" cy="4572000"/>
+            <a:ext cx="3474720" cy="4754880"/>
           </a:xfrm>
           <a:prstGeom prst="rect">
             <a:avLst/>
@@ -4759,7 +4722,6 @@
               <a:srgbClr val="E0E0E0"/>
             </a:solidFill>
           </a:ln>
-          <a:effectLst/>
         </p:spPr>
         <p:style>
           <a:lnRef idx="1">
@@ -4792,7 +4754,7 @@
         <p:spPr>
           <a:xfrm>
             <a:off x="731520" y="1737360"/>
-            <a:ext cx="3108960" cy="457200"/>
+            <a:ext cx="2926079" cy="457200"/>
           </a:xfrm>
           <a:prstGeom prst="rect">
             <a:avLst/>
@@ -4828,7 +4790,7 @@
         <p:spPr>
           <a:xfrm>
             <a:off x="731520" y="2194560"/>
-            <a:ext cx="3108960" cy="3657600"/>
+            <a:ext cx="2926079" cy="3840480"/>
           </a:xfrm>
           <a:prstGeom prst="rect">
             <a:avLst/>
@@ -4843,7 +4805,7 @@
           <a:p>
             <a:pPr>
               <a:spcAft>
-                <a:spcPts val="600"/>
+                <a:spcPts val="400"/>
               </a:spcAft>
               <a:defRPr sz="1300">
                 <a:solidFill>
@@ -4859,7 +4821,7 @@
           <a:p>
             <a:pPr>
               <a:spcAft>
-                <a:spcPts val="600"/>
+                <a:spcPts val="400"/>
               </a:spcAft>
               <a:defRPr sz="1300">
                 <a:solidFill>
@@ -4875,20 +4837,20 @@
           <a:p>
             <a:pPr>
               <a:spcAft>
-                <a:spcPts val="600"/>
-              </a:spcAft>
-              <a:defRPr sz="1300">
-                <a:solidFill>
-                  <a:srgbClr val="2B2B2B"/>
-                </a:solidFill>
-                <a:latin typeface="Calibri"/>
-              </a:defRPr>
-            </a:pPr>
-          </a:p>
-          <a:p>
-            <a:pPr>
-              <a:spcAft>
-                <a:spcPts val="600"/>
+                <a:spcPts val="400"/>
+              </a:spcAft>
+              <a:defRPr sz="1300">
+                <a:solidFill>
+                  <a:srgbClr val="2B2B2B"/>
+                </a:solidFill>
+                <a:latin typeface="Calibri"/>
+              </a:defRPr>
+            </a:pPr>
+          </a:p>
+          <a:p>
+            <a:pPr>
+              <a:spcAft>
+                <a:spcPts val="400"/>
               </a:spcAft>
               <a:defRPr sz="1300">
                 <a:solidFill>
@@ -4904,20 +4866,20 @@
           <a:p>
             <a:pPr>
               <a:spcAft>
-                <a:spcPts val="600"/>
-              </a:spcAft>
-              <a:defRPr sz="1300">
-                <a:solidFill>
-                  <a:srgbClr val="2B2B2B"/>
-                </a:solidFill>
-                <a:latin typeface="Calibri"/>
-              </a:defRPr>
-            </a:pPr>
-          </a:p>
-          <a:p>
-            <a:pPr>
-              <a:spcAft>
-                <a:spcPts val="600"/>
+                <a:spcPts val="400"/>
+              </a:spcAft>
+              <a:defRPr sz="1300">
+                <a:solidFill>
+                  <a:srgbClr val="2B2B2B"/>
+                </a:solidFill>
+                <a:latin typeface="Calibri"/>
+              </a:defRPr>
+            </a:pPr>
+          </a:p>
+          <a:p>
+            <a:pPr>
+              <a:spcAft>
+                <a:spcPts val="400"/>
               </a:spcAft>
               <a:defRPr sz="1300">
                 <a:solidFill>
@@ -4933,7 +4895,7 @@
           <a:p>
             <a:pPr>
               <a:spcAft>
-                <a:spcPts val="600"/>
+                <a:spcPts val="400"/>
               </a:spcAft>
               <a:defRPr sz="1300">
                 <a:solidFill>
@@ -4949,20 +4911,20 @@
           <a:p>
             <a:pPr>
               <a:spcAft>
-                <a:spcPts val="600"/>
-              </a:spcAft>
-              <a:defRPr sz="1300">
-                <a:solidFill>
-                  <a:srgbClr val="2B2B2B"/>
-                </a:solidFill>
-                <a:latin typeface="Calibri"/>
-              </a:defRPr>
-            </a:pPr>
-          </a:p>
-          <a:p>
-            <a:pPr>
-              <a:spcAft>
-                <a:spcPts val="600"/>
+                <a:spcPts val="400"/>
+              </a:spcAft>
+              <a:defRPr sz="1300">
+                <a:solidFill>
+                  <a:srgbClr val="2B2B2B"/>
+                </a:solidFill>
+                <a:latin typeface="Calibri"/>
+              </a:defRPr>
+            </a:pPr>
+          </a:p>
+          <a:p>
+            <a:pPr>
+              <a:spcAft>
+                <a:spcPts val="400"/>
               </a:spcAft>
               <a:defRPr sz="1300">
                 <a:solidFill>
@@ -4986,7 +4948,7 @@
         <p:spPr>
           <a:xfrm>
             <a:off x="4297680" y="1554480"/>
-            <a:ext cx="3657600" cy="4572000"/>
+            <a:ext cx="3474720" cy="4754880"/>
           </a:xfrm>
           <a:prstGeom prst="rect">
             <a:avLst/>
@@ -4999,7 +4961,6 @@
               <a:srgbClr val="E0E0E0"/>
             </a:solidFill>
           </a:ln>
-          <a:effectLst/>
         </p:spPr>
         <p:style>
           <a:lnRef idx="1">
@@ -5032,7 +4993,7 @@
         <p:spPr>
           <a:xfrm>
             <a:off x="4572000" y="1737360"/>
-            <a:ext cx="3108960" cy="457200"/>
+            <a:ext cx="2926079" cy="457200"/>
           </a:xfrm>
           <a:prstGeom prst="rect">
             <a:avLst/>
@@ -5068,7 +5029,7 @@
         <p:spPr>
           <a:xfrm>
             <a:off x="4572000" y="2194560"/>
-            <a:ext cx="3108960" cy="3657600"/>
+            <a:ext cx="2926079" cy="3840480"/>
           </a:xfrm>
           <a:prstGeom prst="rect">
             <a:avLst/>
@@ -5083,7 +5044,7 @@
           <a:p>
             <a:pPr>
               <a:spcAft>
-                <a:spcPts val="600"/>
+                <a:spcPts val="400"/>
               </a:spcAft>
               <a:defRPr sz="1300">
                 <a:solidFill>
@@ -5099,7 +5060,7 @@
           <a:p>
             <a:pPr>
               <a:spcAft>
-                <a:spcPts val="600"/>
+                <a:spcPts val="400"/>
               </a:spcAft>
               <a:defRPr sz="1300">
                 <a:solidFill>
@@ -5115,20 +5076,20 @@
           <a:p>
             <a:pPr>
               <a:spcAft>
-                <a:spcPts val="600"/>
-              </a:spcAft>
-              <a:defRPr sz="1300">
-                <a:solidFill>
-                  <a:srgbClr val="2B2B2B"/>
-                </a:solidFill>
-                <a:latin typeface="Calibri"/>
-              </a:defRPr>
-            </a:pPr>
-          </a:p>
-          <a:p>
-            <a:pPr>
-              <a:spcAft>
-                <a:spcPts val="600"/>
+                <a:spcPts val="400"/>
+              </a:spcAft>
+              <a:defRPr sz="1300">
+                <a:solidFill>
+                  <a:srgbClr val="2B2B2B"/>
+                </a:solidFill>
+                <a:latin typeface="Calibri"/>
+              </a:defRPr>
+            </a:pPr>
+          </a:p>
+          <a:p>
+            <a:pPr>
+              <a:spcAft>
+                <a:spcPts val="400"/>
               </a:spcAft>
               <a:defRPr sz="1300">
                 <a:solidFill>
@@ -5144,7 +5105,7 @@
           <a:p>
             <a:pPr>
               <a:spcAft>
-                <a:spcPts val="600"/>
+                <a:spcPts val="400"/>
               </a:spcAft>
               <a:defRPr sz="1300">
                 <a:solidFill>
@@ -5160,7 +5121,7 @@
           <a:p>
             <a:pPr>
               <a:spcAft>
-                <a:spcPts val="600"/>
+                <a:spcPts val="400"/>
               </a:spcAft>
               <a:defRPr sz="1300">
                 <a:solidFill>
@@ -5176,20 +5137,20 @@
           <a:p>
             <a:pPr>
               <a:spcAft>
-                <a:spcPts val="600"/>
-              </a:spcAft>
-              <a:defRPr sz="1300">
-                <a:solidFill>
-                  <a:srgbClr val="2B2B2B"/>
-                </a:solidFill>
-                <a:latin typeface="Calibri"/>
-              </a:defRPr>
-            </a:pPr>
-          </a:p>
-          <a:p>
-            <a:pPr>
-              <a:spcAft>
-                <a:spcPts val="600"/>
+                <a:spcPts val="400"/>
+              </a:spcAft>
+              <a:defRPr sz="1300">
+                <a:solidFill>
+                  <a:srgbClr val="2B2B2B"/>
+                </a:solidFill>
+                <a:latin typeface="Calibri"/>
+              </a:defRPr>
+            </a:pPr>
+          </a:p>
+          <a:p>
+            <a:pPr>
+              <a:spcAft>
+                <a:spcPts val="400"/>
               </a:spcAft>
               <a:defRPr sz="1300">
                 <a:solidFill>
@@ -5205,7 +5166,7 @@
           <a:p>
             <a:pPr>
               <a:spcAft>
-                <a:spcPts val="600"/>
+                <a:spcPts val="400"/>
               </a:spcAft>
               <a:defRPr sz="1300">
                 <a:solidFill>
@@ -5221,7 +5182,7 @@
           <a:p>
             <a:pPr>
               <a:spcAft>
-                <a:spcPts val="600"/>
+                <a:spcPts val="400"/>
               </a:spcAft>
               <a:defRPr sz="1300">
                 <a:solidFill>
@@ -5245,7 +5206,7 @@
         <p:spPr>
           <a:xfrm>
             <a:off x="8138160" y="1554480"/>
-            <a:ext cx="3657600" cy="4572000"/>
+            <a:ext cx="3474720" cy="4754880"/>
           </a:xfrm>
           <a:prstGeom prst="rect">
             <a:avLst/>
@@ -5258,7 +5219,6 @@
               <a:srgbClr val="E0E0E0"/>
             </a:solidFill>
           </a:ln>
-          <a:effectLst/>
         </p:spPr>
         <p:style>
           <a:lnRef idx="1">
@@ -5291,7 +5251,7 @@
         <p:spPr>
           <a:xfrm>
             <a:off x="8412480" y="1737360"/>
-            <a:ext cx="3108960" cy="457200"/>
+            <a:ext cx="2926079" cy="457200"/>
           </a:xfrm>
           <a:prstGeom prst="rect">
             <a:avLst/>
@@ -5327,7 +5287,7 @@
         <p:spPr>
           <a:xfrm>
             <a:off x="8412480" y="2194560"/>
-            <a:ext cx="3108960" cy="3657600"/>
+            <a:ext cx="2926079" cy="3840480"/>
           </a:xfrm>
           <a:prstGeom prst="rect">
             <a:avLst/>
@@ -5342,7 +5302,7 @@
           <a:p>
             <a:pPr>
               <a:spcAft>
-                <a:spcPts val="600"/>
+                <a:spcPts val="400"/>
               </a:spcAft>
               <a:defRPr sz="1300">
                 <a:solidFill>
@@ -5358,7 +5318,7 @@
           <a:p>
             <a:pPr>
               <a:spcAft>
-                <a:spcPts val="600"/>
+                <a:spcPts val="400"/>
               </a:spcAft>
               <a:defRPr sz="1300">
                 <a:solidFill>
@@ -5374,20 +5334,20 @@
           <a:p>
             <a:pPr>
               <a:spcAft>
-                <a:spcPts val="600"/>
-              </a:spcAft>
-              <a:defRPr sz="1300">
-                <a:solidFill>
-                  <a:srgbClr val="2B2B2B"/>
-                </a:solidFill>
-                <a:latin typeface="Calibri"/>
-              </a:defRPr>
-            </a:pPr>
-          </a:p>
-          <a:p>
-            <a:pPr>
-              <a:spcAft>
-                <a:spcPts val="600"/>
+                <a:spcPts val="400"/>
+              </a:spcAft>
+              <a:defRPr sz="1300">
+                <a:solidFill>
+                  <a:srgbClr val="2B2B2B"/>
+                </a:solidFill>
+                <a:latin typeface="Calibri"/>
+              </a:defRPr>
+            </a:pPr>
+          </a:p>
+          <a:p>
+            <a:pPr>
+              <a:spcAft>
+                <a:spcPts val="400"/>
               </a:spcAft>
               <a:defRPr sz="1300">
                 <a:solidFill>
@@ -5403,7 +5363,7 @@
           <a:p>
             <a:pPr>
               <a:spcAft>
-                <a:spcPts val="600"/>
+                <a:spcPts val="400"/>
               </a:spcAft>
               <a:defRPr sz="1300">
                 <a:solidFill>
@@ -5419,20 +5379,20 @@
           <a:p>
             <a:pPr>
               <a:spcAft>
-                <a:spcPts val="600"/>
-              </a:spcAft>
-              <a:defRPr sz="1300">
-                <a:solidFill>
-                  <a:srgbClr val="2B2B2B"/>
-                </a:solidFill>
-                <a:latin typeface="Calibri"/>
-              </a:defRPr>
-            </a:pPr>
-          </a:p>
-          <a:p>
-            <a:pPr>
-              <a:spcAft>
-                <a:spcPts val="600"/>
+                <a:spcPts val="400"/>
+              </a:spcAft>
+              <a:defRPr sz="1300">
+                <a:solidFill>
+                  <a:srgbClr val="2B2B2B"/>
+                </a:solidFill>
+                <a:latin typeface="Calibri"/>
+              </a:defRPr>
+            </a:pPr>
+          </a:p>
+          <a:p>
+            <a:pPr>
+              <a:spcAft>
+                <a:spcPts val="400"/>
               </a:spcAft>
               <a:defRPr sz="1300">
                 <a:solidFill>
@@ -5448,7 +5408,7 @@
           <a:p>
             <a:pPr>
               <a:spcAft>
-                <a:spcPts val="600"/>
+                <a:spcPts val="400"/>
               </a:spcAft>
               <a:defRPr sz="1300">
                 <a:solidFill>
@@ -5464,7 +5424,7 @@
           <a:p>
             <a:pPr>
               <a:spcAft>
-                <a:spcPts val="600"/>
+                <a:spcPts val="400"/>
               </a:spcAft>
               <a:defRPr sz="1300">
                 <a:solidFill>
@@ -5550,7 +5510,7 @@
         <p:spPr>
           <a:xfrm>
             <a:off x="457200" y="1188720"/>
-            <a:ext cx="5303520" cy="5029200"/>
+            <a:ext cx="3383280" cy="5029200"/>
           </a:xfrm>
           <a:prstGeom prst="rect">
             <a:avLst/>
@@ -5595,7 +5555,7 @@
         <p:spPr>
           <a:xfrm>
             <a:off x="731520" y="1371600"/>
-            <a:ext cx="4754880" cy="457200"/>
+            <a:ext cx="2834640" cy="457200"/>
           </a:xfrm>
           <a:prstGeom prst="rect">
             <a:avLst/>
@@ -5609,7 +5569,7 @@
           <a:lstStyle/>
           <a:p>
             <a:pPr algn="l">
-              <a:defRPr sz="2000" b="1">
+              <a:defRPr sz="1800" b="1">
                 <a:solidFill>
                   <a:srgbClr val="0078D4"/>
                 </a:solidFill>
@@ -5630,8 +5590,8 @@
         </p:nvSpPr>
         <p:spPr>
           <a:xfrm>
-            <a:off x="731520" y="1920240"/>
-            <a:ext cx="4754880" cy="4114800"/>
+            <a:off x="731520" y="1828800"/>
+            <a:ext cx="2834640" cy="4114800"/>
           </a:xfrm>
           <a:prstGeom prst="rect">
             <a:avLst/>
@@ -5646,9 +5606,9 @@
           <a:p>
             <a:pPr>
               <a:spcAft>
-                <a:spcPts val="600"/>
-              </a:spcAft>
-              <a:defRPr sz="1400">
+                <a:spcPts val="400"/>
+              </a:spcAft>
+              <a:defRPr sz="1300">
                 <a:solidFill>
                   <a:srgbClr val="2B2B2B"/>
                 </a:solidFill>
@@ -5662,9 +5622,9 @@
           <a:p>
             <a:pPr>
               <a:spcAft>
-                <a:spcPts val="600"/>
-              </a:spcAft>
-              <a:defRPr sz="1400">
+                <a:spcPts val="400"/>
+              </a:spcAft>
+              <a:defRPr sz="1300">
                 <a:solidFill>
                   <a:srgbClr val="2B2B2B"/>
                 </a:solidFill>
@@ -5678,9 +5638,9 @@
           <a:p>
             <a:pPr>
               <a:spcAft>
-                <a:spcPts val="600"/>
-              </a:spcAft>
-              <a:defRPr sz="1400">
+                <a:spcPts val="400"/>
+              </a:spcAft>
+              <a:defRPr sz="1300">
                 <a:solidFill>
                   <a:srgbClr val="2B2B2B"/>
                 </a:solidFill>
@@ -5694,9 +5654,9 @@
           <a:p>
             <a:pPr>
               <a:spcAft>
-                <a:spcPts val="600"/>
-              </a:spcAft>
-              <a:defRPr sz="1400">
+                <a:spcPts val="400"/>
+              </a:spcAft>
+              <a:defRPr sz="1300">
                 <a:solidFill>
                   <a:srgbClr val="2B2B2B"/>
                 </a:solidFill>
@@ -5710,9 +5670,9 @@
           <a:p>
             <a:pPr>
               <a:spcAft>
-                <a:spcPts val="600"/>
-              </a:spcAft>
-              <a:defRPr sz="1400">
+                <a:spcPts val="400"/>
+              </a:spcAft>
+              <a:defRPr sz="1300">
                 <a:solidFill>
                   <a:srgbClr val="2B2B2B"/>
                 </a:solidFill>
@@ -5726,38 +5686,38 @@
           <a:p>
             <a:pPr>
               <a:spcAft>
-                <a:spcPts val="600"/>
-              </a:spcAft>
-              <a:defRPr sz="1400">
-                <a:solidFill>
-                  <a:srgbClr val="2B2B2B"/>
-                </a:solidFill>
-                <a:latin typeface="Calibri"/>
-              </a:defRPr>
-            </a:pPr>
-          </a:p>
-          <a:p>
-            <a:pPr>
-              <a:spcAft>
-                <a:spcPts val="600"/>
-              </a:spcAft>
-              <a:defRPr sz="1400">
-                <a:solidFill>
-                  <a:srgbClr val="2B2B2B"/>
-                </a:solidFill>
-                <a:latin typeface="Calibri"/>
-              </a:defRPr>
-            </a:pPr>
-            <a:r>
-              <a:t>✅ Pour réutiliser:</a:t>
-            </a:r>
-          </a:p>
-          <a:p>
-            <a:pPr>
-              <a:spcAft>
-                <a:spcPts val="600"/>
-              </a:spcAft>
-              <a:defRPr sz="1400">
+                <a:spcPts val="400"/>
+              </a:spcAft>
+              <a:defRPr sz="1300">
+                <a:solidFill>
+                  <a:srgbClr val="2B2B2B"/>
+                </a:solidFill>
+                <a:latin typeface="Calibri"/>
+              </a:defRPr>
+            </a:pPr>
+          </a:p>
+          <a:p>
+            <a:pPr>
+              <a:spcAft>
+                <a:spcPts val="400"/>
+              </a:spcAft>
+              <a:defRPr sz="1300">
+                <a:solidFill>
+                  <a:srgbClr val="2B2B2B"/>
+                </a:solidFill>
+                <a:latin typeface="Calibri"/>
+              </a:defRPr>
+            </a:pPr>
+            <a:r>
+              <a:t>✅ Réutiliser:</a:t>
+            </a:r>
+          </a:p>
+          <a:p>
+            <a:pPr>
+              <a:spcAft>
+                <a:spcPts val="400"/>
+              </a:spcAft>
+              <a:defRPr sz="1300">
                 <a:solidFill>
                   <a:srgbClr val="2B2B2B"/>
                 </a:solidFill>
@@ -5771,46 +5731,30 @@
           <a:p>
             <a:pPr>
               <a:spcAft>
-                <a:spcPts val="600"/>
-              </a:spcAft>
-              <a:defRPr sz="1400">
-                <a:solidFill>
-                  <a:srgbClr val="2B2B2B"/>
-                </a:solidFill>
-                <a:latin typeface="Calibri"/>
-              </a:defRPr>
-            </a:pPr>
-          </a:p>
-          <a:p>
-            <a:pPr>
-              <a:spcAft>
-                <a:spcPts val="600"/>
-              </a:spcAft>
-              <a:defRPr sz="1400">
-                <a:solidFill>
-                  <a:srgbClr val="2B2B2B"/>
-                </a:solidFill>
-                <a:latin typeface="Calibri"/>
-              </a:defRPr>
-            </a:pPr>
-            <a:r>
-              <a:t>💡 Astuce: Créez-en 3-4 pour vos</a:t>
-            </a:r>
-          </a:p>
-          <a:p>
-            <a:pPr>
-              <a:spcAft>
-                <a:spcPts val="600"/>
-              </a:spcAft>
-              <a:defRPr sz="1400">
-                <a:solidFill>
-                  <a:srgbClr val="2B2B2B"/>
-                </a:solidFill>
-                <a:latin typeface="Calibri"/>
-              </a:defRPr>
-            </a:pPr>
-            <a:r>
-              <a:t>tâches les plus fréquentes!</a:t>
+                <a:spcPts val="400"/>
+              </a:spcAft>
+              <a:defRPr sz="1300">
+                <a:solidFill>
+                  <a:srgbClr val="2B2B2B"/>
+                </a:solidFill>
+                <a:latin typeface="Calibri"/>
+              </a:defRPr>
+            </a:pPr>
+          </a:p>
+          <a:p>
+            <a:pPr>
+              <a:spcAft>
+                <a:spcPts val="400"/>
+              </a:spcAft>
+              <a:defRPr sz="1300">
+                <a:solidFill>
+                  <a:srgbClr val="2B2B2B"/>
+                </a:solidFill>
+                <a:latin typeface="Calibri"/>
+              </a:defRPr>
+            </a:pPr>
+            <a:r>
+              <a:t>💡 Créez-en 3-4 pour vos tâches fréquentes!</a:t>
             </a:r>
           </a:p>
         </p:txBody>
@@ -5823,8 +5767,8 @@
         </p:nvSpPr>
         <p:spPr>
           <a:xfrm>
-            <a:off x="6217920" y="1188720"/>
-            <a:ext cx="5486400" cy="2286000"/>
+            <a:off x="4114800" y="1188720"/>
+            <a:ext cx="3383280" cy="5029200"/>
           </a:xfrm>
           <a:prstGeom prst="rect">
             <a:avLst/>
@@ -5868,8 +5812,8 @@
         </p:nvSpPr>
         <p:spPr>
           <a:xfrm>
-            <a:off x="6492240" y="1371600"/>
-            <a:ext cx="5029200" cy="457200"/>
+            <a:off x="4389120" y="1371600"/>
+            <a:ext cx="2834640" cy="457200"/>
           </a:xfrm>
           <a:prstGeom prst="rect">
             <a:avLst/>
@@ -5904,8 +5848,8 @@
         </p:nvSpPr>
         <p:spPr>
           <a:xfrm>
-            <a:off x="6492240" y="1920240"/>
-            <a:ext cx="5029200" cy="1371600"/>
+            <a:off x="4389120" y="1828800"/>
+            <a:ext cx="2834640" cy="4114800"/>
           </a:xfrm>
           <a:prstGeom prst="rect">
             <a:avLst/>
@@ -5920,9 +5864,9 @@
           <a:p>
             <a:pPr>
               <a:spcAft>
-                <a:spcPts val="600"/>
-              </a:spcAft>
-              <a:defRPr sz="1400">
+                <a:spcPts val="400"/>
+              </a:spcAft>
+              <a:defRPr sz="1300">
                 <a:solidFill>
                   <a:srgbClr val="2B2B2B"/>
                 </a:solidFill>
@@ -5936,9 +5880,9 @@
           <a:p>
             <a:pPr>
               <a:spcAft>
-                <a:spcPts val="600"/>
-              </a:spcAft>
-              <a:defRPr sz="1400">
+                <a:spcPts val="400"/>
+              </a:spcAft>
+              <a:defRPr sz="1300">
                 <a:solidFill>
                   <a:srgbClr val="2B2B2B"/>
                 </a:solidFill>
@@ -5952,9 +5896,9 @@
           <a:p>
             <a:pPr>
               <a:spcAft>
-                <a:spcPts val="600"/>
-              </a:spcAft>
-              <a:defRPr sz="1400">
+                <a:spcPts val="400"/>
+              </a:spcAft>
+              <a:defRPr sz="1300">
                 <a:solidFill>
                   <a:srgbClr val="2B2B2B"/>
                 </a:solidFill>
@@ -5975,8 +5919,8 @@
         </p:nvSpPr>
         <p:spPr>
           <a:xfrm>
-            <a:off x="6217920" y="3840480"/>
-            <a:ext cx="5486400" cy="2286000"/>
+            <a:off x="7772400" y="1188720"/>
+            <a:ext cx="3383280" cy="5029200"/>
           </a:xfrm>
           <a:prstGeom prst="rect">
             <a:avLst/>
@@ -6020,8 +5964,8 @@
         </p:nvSpPr>
         <p:spPr>
           <a:xfrm>
-            <a:off x="6492240" y="4023360"/>
-            <a:ext cx="5029200" cy="457200"/>
+            <a:off x="8046720" y="1371600"/>
+            <a:ext cx="2834640" cy="457200"/>
           </a:xfrm>
           <a:prstGeom prst="rect">
             <a:avLst/>
@@ -6056,8 +6000,8 @@
         </p:nvSpPr>
         <p:spPr>
           <a:xfrm>
-            <a:off x="6492240" y="4572000"/>
-            <a:ext cx="5029200" cy="1371600"/>
+            <a:off x="8046720" y="1828800"/>
+            <a:ext cx="2834640" cy="4114800"/>
           </a:xfrm>
           <a:prstGeom prst="rect">
             <a:avLst/>
@@ -6072,9 +6016,9 @@
           <a:p>
             <a:pPr>
               <a:spcAft>
-                <a:spcPts val="600"/>
-              </a:spcAft>
-              <a:defRPr sz="1400">
+                <a:spcPts val="400"/>
+              </a:spcAft>
+              <a:defRPr sz="1300">
                 <a:solidFill>
                   <a:srgbClr val="2B2B2B"/>
                 </a:solidFill>
@@ -6088,9 +6032,9 @@
           <a:p>
             <a:pPr>
               <a:spcAft>
-                <a:spcPts val="600"/>
-              </a:spcAft>
-              <a:defRPr sz="1400">
+                <a:spcPts val="400"/>
+              </a:spcAft>
+              <a:defRPr sz="1300">
                 <a:solidFill>
                   <a:srgbClr val="2B2B2B"/>
                 </a:solidFill>
@@ -6104,9 +6048,9 @@
           <a:p>
             <a:pPr>
               <a:spcAft>
-                <a:spcPts val="600"/>
-              </a:spcAft>
-              <a:defRPr sz="1400">
+                <a:spcPts val="400"/>
+              </a:spcAft>
+              <a:defRPr sz="1300">
                 <a:solidFill>
                   <a:srgbClr val="2B2B2B"/>
                 </a:solidFill>
@@ -6189,7 +6133,7 @@
         </p:nvSpPr>
         <p:spPr>
           <a:xfrm>
-            <a:off x="457200" y="2011680"/>
+            <a:off x="365760" y="2011680"/>
             <a:ext cx="3474720" cy="2286000"/>
           </a:xfrm>
           <a:prstGeom prst="rect">
@@ -6200,7 +6144,7 @@
           </a:solidFill>
           <a:ln>
             <a:solidFill>
-              <a:srgbClr val="CCE5FF"/>
+              <a:srgbClr val="AAD4F0"/>
             </a:solidFill>
           </a:ln>
         </p:spPr>
@@ -6234,8 +6178,8 @@
         </p:nvSpPr>
         <p:spPr>
           <a:xfrm>
-            <a:off x="731520" y="2194560"/>
-            <a:ext cx="2926080" cy="548640"/>
+            <a:off x="640080" y="2194560"/>
+            <a:ext cx="2926079" cy="548640"/>
           </a:xfrm>
           <a:prstGeom prst="rect">
             <a:avLst/>
@@ -6270,8 +6214,8 @@
         </p:nvSpPr>
         <p:spPr>
           <a:xfrm>
-            <a:off x="731520" y="2926080"/>
-            <a:ext cx="2926080" cy="914400"/>
+            <a:off x="640080" y="2926080"/>
+            <a:ext cx="2926079" cy="914400"/>
           </a:xfrm>
           <a:prstGeom prst="rect">
             <a:avLst/>
@@ -6310,7 +6254,7 @@
         </p:nvSpPr>
         <p:spPr>
           <a:xfrm>
-            <a:off x="4389120" y="2011680"/>
+            <a:off x="3749040" y="2011680"/>
             <a:ext cx="3474720" cy="2286000"/>
           </a:xfrm>
           <a:prstGeom prst="rect">
@@ -6321,7 +6265,7 @@
           </a:solidFill>
           <a:ln>
             <a:solidFill>
-              <a:srgbClr val="CCE5FF"/>
+              <a:srgbClr val="AAD4F0"/>
             </a:solidFill>
           </a:ln>
         </p:spPr>
@@ -6355,8 +6299,8 @@
         </p:nvSpPr>
         <p:spPr>
           <a:xfrm>
-            <a:off x="4663440" y="2194560"/>
-            <a:ext cx="2926080" cy="548640"/>
+            <a:off x="4023360" y="2194560"/>
+            <a:ext cx="2926079" cy="548640"/>
           </a:xfrm>
           <a:prstGeom prst="rect">
             <a:avLst/>
@@ -6391,8 +6335,8 @@
         </p:nvSpPr>
         <p:spPr>
           <a:xfrm>
-            <a:off x="4663440" y="2926080"/>
-            <a:ext cx="2926080" cy="914400"/>
+            <a:off x="4023360" y="2926080"/>
+            <a:ext cx="2926079" cy="914400"/>
           </a:xfrm>
           <a:prstGeom prst="rect">
             <a:avLst/>
@@ -6431,7 +6375,7 @@
         </p:nvSpPr>
         <p:spPr>
           <a:xfrm>
-            <a:off x="8321040" y="2011680"/>
+            <a:off x="7132320" y="2011680"/>
             <a:ext cx="3474720" cy="2286000"/>
           </a:xfrm>
           <a:prstGeom prst="rect">
@@ -6442,7 +6386,7 @@
           </a:solidFill>
           <a:ln>
             <a:solidFill>
-              <a:srgbClr val="CCE5FF"/>
+              <a:srgbClr val="AAD4F0"/>
             </a:solidFill>
           </a:ln>
         </p:spPr>
@@ -6476,8 +6420,8 @@
         </p:nvSpPr>
         <p:spPr>
           <a:xfrm>
-            <a:off x="8595360" y="2194560"/>
-            <a:ext cx="2926080" cy="548640"/>
+            <a:off x="7406640" y="2194560"/>
+            <a:ext cx="2926079" cy="548640"/>
           </a:xfrm>
           <a:prstGeom prst="rect">
             <a:avLst/>
@@ -6512,8 +6456,8 @@
         </p:nvSpPr>
         <p:spPr>
           <a:xfrm>
-            <a:off x="8595360" y="2926080"/>
-            <a:ext cx="2926080" cy="914400"/>
+            <a:off x="7406640" y="2926080"/>
+            <a:ext cx="2926079" cy="914400"/>
           </a:xfrm>
           <a:prstGeom prst="rect">
             <a:avLst/>

</xml_diff>

<commit_message>
Update JSON schema: titre + bullets + speaker_notes
- JSON: chaque slide a title, bullets, speaker_notes
- Parser: affiche les bullets, intègre les notes du présentateur
- Quiz: le présentateur voit ses notes dans PowerPoint (en bas)
</commit_message>
<xml_diff>
--- a/presentations/La_Minute_Copilot_Outlook.pptx
+++ b/presentations/La_Minute_Copilot_Outlook.pptx
@@ -6,11 +6,11 @@
   </p:sldMasterIdLst>
   <p:sldIdLst>
     <p:sldId id="256" r:id="rId7"/>
-    <p:sldId id="257" r:id="rId8"/>
-    <p:sldId id="258" r:id="rId9"/>
-    <p:sldId id="259" r:id="rId10"/>
-    <p:sldId id="260" r:id="rId11"/>
-    <p:sldId id="261" r:id="rId12"/>
+    <p:sldId id="257" r:id="rId9"/>
+    <p:sldId id="258" r:id="rId10"/>
+    <p:sldId id="259" r:id="rId11"/>
+    <p:sldId id="260" r:id="rId12"/>
+    <p:sldId id="261" r:id="rId13"/>
   </p:sldIdLst>
   <p:sldSz cx="12188952" cy="6858000" type="screen4x3"/>
   <p:notesSz cx="6858000" cy="9144000"/>
@@ -110,6 +110,776 @@
     </a:lvl9pPr>
   </p:defaultTextStyle>
 </p:presentation>
+</file>
+
+<file path=ppt/notesMasters/notesMaster1.xml><?xml version="1.0" encoding="utf-8"?>
+<p:notesMaster xmlns:a="http://schemas.openxmlformats.org/drawingml/2006/main" xmlns:p="http://schemas.openxmlformats.org/presentationml/2006/main" xmlns:r="http://schemas.openxmlformats.org/officeDocument/2006/relationships">
+  <p:cSld>
+    <p:bg>
+      <p:bgRef idx="1001">
+        <a:schemeClr val="bg1"/>
+      </p:bgRef>
+    </p:bg>
+    <p:spTree>
+      <p:nvGrpSpPr>
+        <p:cNvPr id="1" name=""/>
+        <p:cNvGrpSpPr/>
+        <p:nvPr/>
+      </p:nvGrpSpPr>
+      <p:grpSpPr>
+        <a:xfrm>
+          <a:off x="0" y="0"/>
+          <a:ext cx="0" cy="0"/>
+          <a:chOff x="0" y="0"/>
+          <a:chExt cx="0" cy="0"/>
+        </a:xfrm>
+      </p:grpSpPr>
+      <p:sp>
+        <p:nvSpPr>
+          <p:cNvPr id="2" name="Header Placeholder 1"/>
+          <p:cNvSpPr>
+            <a:spLocks noGrp="1"/>
+          </p:cNvSpPr>
+          <p:nvPr>
+            <p:ph type="hdr" sz="quarter"/>
+          </p:nvPr>
+        </p:nvSpPr>
+        <p:spPr>
+          <a:xfrm>
+            <a:off x="0" y="0"/>
+            <a:ext cx="2971800" cy="457200"/>
+          </a:xfrm>
+          <a:prstGeom prst="rect">
+            <a:avLst/>
+          </a:prstGeom>
+        </p:spPr>
+        <p:txBody>
+          <a:bodyPr vert="horz" lIns="91440" tIns="45720" rIns="91440" bIns="45720" rtlCol="0"/>
+          <a:lstStyle>
+            <a:lvl1pPr algn="l">
+              <a:defRPr sz="1200"/>
+            </a:lvl1pPr>
+          </a:lstStyle>
+          <a:p>
+            <a:endParaRPr lang="en-US"/>
+          </a:p>
+        </p:txBody>
+      </p:sp>
+      <p:sp>
+        <p:nvSpPr>
+          <p:cNvPr id="3" name="Date Placeholder 2"/>
+          <p:cNvSpPr>
+            <a:spLocks noGrp="1"/>
+          </p:cNvSpPr>
+          <p:nvPr>
+            <p:ph type="dt" idx="1"/>
+          </p:nvPr>
+        </p:nvSpPr>
+        <p:spPr>
+          <a:xfrm>
+            <a:off x="3884613" y="0"/>
+            <a:ext cx="2971800" cy="457200"/>
+          </a:xfrm>
+          <a:prstGeom prst="rect">
+            <a:avLst/>
+          </a:prstGeom>
+        </p:spPr>
+        <p:txBody>
+          <a:bodyPr vert="horz" lIns="91440" tIns="45720" rIns="91440" bIns="45720" rtlCol="0"/>
+          <a:lstStyle>
+            <a:lvl1pPr algn="r">
+              <a:defRPr sz="1200"/>
+            </a:lvl1pPr>
+          </a:lstStyle>
+          <a:p>
+            <a:fld id="{0F89C1C7-3DCD-1040-A9CF-14679D8B5DDD}" type="datetimeFigureOut">
+              <a:rPr lang="en-US" smtClean="0"/>
+              <a:t>10/17/16</a:t>
+            </a:fld>
+            <a:endParaRPr lang="en-US"/>
+          </a:p>
+        </p:txBody>
+      </p:sp>
+      <p:sp>
+        <p:nvSpPr>
+          <p:cNvPr id="4" name="Slide Image Placeholder 3"/>
+          <p:cNvSpPr>
+            <a:spLocks noGrp="1" noRot="1" noChangeAspect="1"/>
+          </p:cNvSpPr>
+          <p:nvPr>
+            <p:ph type="sldImg" idx="2"/>
+          </p:nvPr>
+        </p:nvSpPr>
+        <p:spPr>
+          <a:xfrm>
+            <a:off x="1143000" y="685800"/>
+            <a:ext cx="4572000" cy="3429000"/>
+          </a:xfrm>
+          <a:prstGeom prst="rect">
+            <a:avLst/>
+          </a:prstGeom>
+          <a:noFill/>
+          <a:ln w="12700">
+            <a:solidFill>
+              <a:prstClr val="black"/>
+            </a:solidFill>
+          </a:ln>
+        </p:spPr>
+        <p:txBody>
+          <a:bodyPr vert="horz" lIns="91440" tIns="45720" rIns="91440" bIns="45720" rtlCol="0" anchor="ctr"/>
+          <a:lstStyle/>
+          <a:p>
+            <a:endParaRPr lang="en-US"/>
+          </a:p>
+        </p:txBody>
+      </p:sp>
+      <p:sp>
+        <p:nvSpPr>
+          <p:cNvPr id="5" name="Notes Placeholder 4"/>
+          <p:cNvSpPr>
+            <a:spLocks noGrp="1"/>
+          </p:cNvSpPr>
+          <p:nvPr>
+            <p:ph type="body" sz="quarter" idx="3"/>
+          </p:nvPr>
+        </p:nvSpPr>
+        <p:spPr>
+          <a:xfrm>
+            <a:off x="685800" y="4343400"/>
+            <a:ext cx="5486400" cy="4114800"/>
+          </a:xfrm>
+          <a:prstGeom prst="rect">
+            <a:avLst/>
+          </a:prstGeom>
+        </p:spPr>
+        <p:txBody>
+          <a:bodyPr vert="horz" lIns="91440" tIns="45720" rIns="91440" bIns="45720" rtlCol="0"/>
+          <a:lstStyle/>
+          <a:p>
+            <a:pPr lvl="0"/>
+            <a:r>
+              <a:rPr lang="en-US" smtClean="0"/>
+              <a:t>Click to edit Master text styles</a:t>
+            </a:r>
+          </a:p>
+          <a:p>
+            <a:pPr lvl="1"/>
+            <a:r>
+              <a:rPr lang="en-US" smtClean="0"/>
+              <a:t>Second level</a:t>
+            </a:r>
+          </a:p>
+          <a:p>
+            <a:pPr lvl="2"/>
+            <a:r>
+              <a:rPr lang="en-US" smtClean="0"/>
+              <a:t>Third level</a:t>
+            </a:r>
+          </a:p>
+          <a:p>
+            <a:pPr lvl="3"/>
+            <a:r>
+              <a:rPr lang="en-US" smtClean="0"/>
+              <a:t>Fourth level</a:t>
+            </a:r>
+          </a:p>
+          <a:p>
+            <a:pPr lvl="4"/>
+            <a:r>
+              <a:rPr lang="en-US" smtClean="0"/>
+              <a:t>Fifth level</a:t>
+            </a:r>
+            <a:endParaRPr lang="en-US"/>
+          </a:p>
+        </p:txBody>
+      </p:sp>
+      <p:sp>
+        <p:nvSpPr>
+          <p:cNvPr id="6" name="Footer Placeholder 5"/>
+          <p:cNvSpPr>
+            <a:spLocks noGrp="1"/>
+          </p:cNvSpPr>
+          <p:nvPr>
+            <p:ph type="ftr" sz="quarter" idx="4"/>
+          </p:nvPr>
+        </p:nvSpPr>
+        <p:spPr>
+          <a:xfrm>
+            <a:off x="0" y="8685213"/>
+            <a:ext cx="2971800" cy="457200"/>
+          </a:xfrm>
+          <a:prstGeom prst="rect">
+            <a:avLst/>
+          </a:prstGeom>
+        </p:spPr>
+        <p:txBody>
+          <a:bodyPr vert="horz" lIns="91440" tIns="45720" rIns="91440" bIns="45720" rtlCol="0" anchor="b"/>
+          <a:lstStyle>
+            <a:lvl1pPr algn="l">
+              <a:defRPr sz="1200"/>
+            </a:lvl1pPr>
+          </a:lstStyle>
+          <a:p>
+            <a:endParaRPr lang="en-US"/>
+          </a:p>
+        </p:txBody>
+      </p:sp>
+      <p:sp>
+        <p:nvSpPr>
+          <p:cNvPr id="7" name="Slide Number Placeholder 6"/>
+          <p:cNvSpPr>
+            <a:spLocks noGrp="1"/>
+          </p:cNvSpPr>
+          <p:nvPr>
+            <p:ph type="sldNum" sz="quarter" idx="5"/>
+          </p:nvPr>
+        </p:nvSpPr>
+        <p:spPr>
+          <a:xfrm>
+            <a:off x="3884613" y="8685213"/>
+            <a:ext cx="2971800" cy="457200"/>
+          </a:xfrm>
+          <a:prstGeom prst="rect">
+            <a:avLst/>
+          </a:prstGeom>
+        </p:spPr>
+        <p:txBody>
+          <a:bodyPr vert="horz" lIns="91440" tIns="45720" rIns="91440" bIns="45720" rtlCol="0" anchor="b"/>
+          <a:lstStyle>
+            <a:lvl1pPr algn="r">
+              <a:defRPr sz="1200"/>
+            </a:lvl1pPr>
+          </a:lstStyle>
+          <a:p>
+            <a:fld id="{BB5E49A5-4136-284D-997B-48E1D791AD67}" type="slidenum">
+              <a:rPr lang="en-US" smtClean="0"/>
+              <a:t>‹#›</a:t>
+            </a:fld>
+            <a:endParaRPr lang="en-US"/>
+          </a:p>
+        </p:txBody>
+      </p:sp>
+    </p:spTree>
+    <p:extLst>
+      <p:ext uri="{BB962C8B-B14F-4D97-AF65-F5344CB8AC3E}">
+        <p14:creationId xmlns:p14="http://schemas.microsoft.com/office/powerpoint/2010/main" val="2623252185"/>
+      </p:ext>
+    </p:extLst>
+  </p:cSld>
+  <p:clrMap bg1="lt1" tx1="dk1" bg2="lt2" tx2="dk2" accent1="accent1" accent2="accent2" accent3="accent3" accent4="accent4" accent5="accent5" accent6="accent6" hlink="hlink" folHlink="folHlink"/>
+  <p:notesStyle>
+    <a:lvl1pPr marL="0" algn="l" defTabSz="457200" rtl="0" eaLnBrk="1" latinLnBrk="0" hangingPunct="1">
+      <a:defRPr sz="1200" kern="1200">
+        <a:solidFill>
+          <a:schemeClr val="tx1"/>
+        </a:solidFill>
+        <a:latin typeface="+mn-lt"/>
+        <a:ea typeface="+mn-ea"/>
+        <a:cs typeface="+mn-cs"/>
+      </a:defRPr>
+    </a:lvl1pPr>
+    <a:lvl2pPr marL="457200" algn="l" defTabSz="457200" rtl="0" eaLnBrk="1" latinLnBrk="0" hangingPunct="1">
+      <a:defRPr sz="1200" kern="1200">
+        <a:solidFill>
+          <a:schemeClr val="tx1"/>
+        </a:solidFill>
+        <a:latin typeface="+mn-lt"/>
+        <a:ea typeface="+mn-ea"/>
+        <a:cs typeface="+mn-cs"/>
+      </a:defRPr>
+    </a:lvl2pPr>
+    <a:lvl3pPr marL="914400" algn="l" defTabSz="457200" rtl="0" eaLnBrk="1" latinLnBrk="0" hangingPunct="1">
+      <a:defRPr sz="1200" kern="1200">
+        <a:solidFill>
+          <a:schemeClr val="tx1"/>
+        </a:solidFill>
+        <a:latin typeface="+mn-lt"/>
+        <a:ea typeface="+mn-ea"/>
+        <a:cs typeface="+mn-cs"/>
+      </a:defRPr>
+    </a:lvl3pPr>
+    <a:lvl4pPr marL="1371600" algn="l" defTabSz="457200" rtl="0" eaLnBrk="1" latinLnBrk="0" hangingPunct="1">
+      <a:defRPr sz="1200" kern="1200">
+        <a:solidFill>
+          <a:schemeClr val="tx1"/>
+        </a:solidFill>
+        <a:latin typeface="+mn-lt"/>
+        <a:ea typeface="+mn-ea"/>
+        <a:cs typeface="+mn-cs"/>
+      </a:defRPr>
+    </a:lvl4pPr>
+    <a:lvl5pPr marL="1828800" algn="l" defTabSz="457200" rtl="0" eaLnBrk="1" latinLnBrk="0" hangingPunct="1">
+      <a:defRPr sz="1200" kern="1200">
+        <a:solidFill>
+          <a:schemeClr val="tx1"/>
+        </a:solidFill>
+        <a:latin typeface="+mn-lt"/>
+        <a:ea typeface="+mn-ea"/>
+        <a:cs typeface="+mn-cs"/>
+      </a:defRPr>
+    </a:lvl5pPr>
+    <a:lvl6pPr marL="2286000" algn="l" defTabSz="457200" rtl="0" eaLnBrk="1" latinLnBrk="0" hangingPunct="1">
+      <a:defRPr sz="1200" kern="1200">
+        <a:solidFill>
+          <a:schemeClr val="tx1"/>
+        </a:solidFill>
+        <a:latin typeface="+mn-lt"/>
+        <a:ea typeface="+mn-ea"/>
+        <a:cs typeface="+mn-cs"/>
+      </a:defRPr>
+    </a:lvl6pPr>
+    <a:lvl7pPr marL="2743200" algn="l" defTabSz="457200" rtl="0" eaLnBrk="1" latinLnBrk="0" hangingPunct="1">
+      <a:defRPr sz="1200" kern="1200">
+        <a:solidFill>
+          <a:schemeClr val="tx1"/>
+        </a:solidFill>
+        <a:latin typeface="+mn-lt"/>
+        <a:ea typeface="+mn-ea"/>
+        <a:cs typeface="+mn-cs"/>
+      </a:defRPr>
+    </a:lvl7pPr>
+    <a:lvl8pPr marL="3200400" algn="l" defTabSz="457200" rtl="0" eaLnBrk="1" latinLnBrk="0" hangingPunct="1">
+      <a:defRPr sz="1200" kern="1200">
+        <a:solidFill>
+          <a:schemeClr val="tx1"/>
+        </a:solidFill>
+        <a:latin typeface="+mn-lt"/>
+        <a:ea typeface="+mn-ea"/>
+        <a:cs typeface="+mn-cs"/>
+      </a:defRPr>
+    </a:lvl8pPr>
+    <a:lvl9pPr marL="3657600" algn="l" defTabSz="457200" rtl="0" eaLnBrk="1" latinLnBrk="0" hangingPunct="1">
+      <a:defRPr sz="1200" kern="1200">
+        <a:solidFill>
+          <a:schemeClr val="tx1"/>
+        </a:solidFill>
+        <a:latin typeface="+mn-lt"/>
+        <a:ea typeface="+mn-ea"/>
+        <a:cs typeface="+mn-cs"/>
+      </a:defRPr>
+    </a:lvl9pPr>
+  </p:notesStyle>
+</p:notesMaster>
+</file>
+
+<file path=ppt/notesSlides/notesSlide1.xml><?xml version="1.0" encoding="utf-8"?>
+<p:notes xmlns:a="http://schemas.openxmlformats.org/drawingml/2006/main" xmlns:p="http://schemas.openxmlformats.org/presentationml/2006/main" xmlns:r="http://schemas.openxmlformats.org/officeDocument/2006/relationships">
+  <p:cSld>
+    <p:spTree>
+      <p:nvGrpSpPr>
+        <p:cNvPr id="1" name=""/>
+        <p:cNvGrpSpPr/>
+        <p:nvPr/>
+      </p:nvGrpSpPr>
+      <p:grpSpPr>
+        <a:xfrm>
+          <a:off x="0" y="0"/>
+          <a:ext cx="0" cy="0"/>
+          <a:chOff x="0" y="0"/>
+          <a:chExt cx="0" cy="0"/>
+        </a:xfrm>
+      </p:grpSpPr>
+      <p:sp>
+        <p:nvSpPr>
+          <p:cNvPr id="2" name="Slide Image Placeholder 1"/>
+          <p:cNvSpPr>
+            <a:spLocks noGrp="1"/>
+          </p:cNvSpPr>
+          <p:nvPr>
+            <p:ph type="sldImg" idx="2"/>
+          </p:nvPr>
+        </p:nvSpPr>
+        <p:spPr/>
+      </p:sp>
+      <p:sp>
+        <p:nvSpPr>
+          <p:cNvPr id="3" name="Notes Placeholder 2"/>
+          <p:cNvSpPr>
+            <a:spLocks noGrp="1"/>
+          </p:cNvSpPr>
+          <p:nvPr>
+            <p:ph type="body" idx="3" sz="quarter"/>
+          </p:nvPr>
+        </p:nvSpPr>
+        <p:spPr/>
+        <p:txBody>
+          <a:bodyPr/>
+          <a:lstStyle/>
+          <a:p>
+            <a:r>
+              <a:t>Accueil: «Bonjour à tous! Bienvenue à cette nouvelle minute Copilot. Aujourd'hui on va voir comment Copilot peut vous faire gagner du temps dans Outlook, même avec la version de base.»</a:t>
+            </a:r>
+          </a:p>
+        </p:txBody>
+      </p:sp>
+      <p:sp>
+        <p:nvSpPr>
+          <p:cNvPr id="4" name="Slide Number Placeholder 3"/>
+          <p:cNvSpPr>
+            <a:spLocks noGrp="1"/>
+          </p:cNvSpPr>
+          <p:nvPr>
+            <p:ph type="sldNum" idx="5" sz="quarter"/>
+          </p:nvPr>
+        </p:nvSpPr>
+        <p:spPr/>
+      </p:sp>
+    </p:spTree>
+  </p:cSld>
+  <p:clrMapOvr>
+    <a:masterClrMapping/>
+  </p:clrMapOvr>
+</p:notes>
+</file>
+
+<file path=ppt/notesSlides/notesSlide2.xml><?xml version="1.0" encoding="utf-8"?>
+<p:notes xmlns:a="http://schemas.openxmlformats.org/drawingml/2006/main" xmlns:p="http://schemas.openxmlformats.org/presentationml/2006/main" xmlns:r="http://schemas.openxmlformats.org/officeDocument/2006/relationships">
+  <p:cSld>
+    <p:spTree>
+      <p:nvGrpSpPr>
+        <p:cNvPr id="1" name=""/>
+        <p:cNvGrpSpPr/>
+        <p:nvPr/>
+      </p:nvGrpSpPr>
+      <p:grpSpPr>
+        <a:xfrm>
+          <a:off x="0" y="0"/>
+          <a:ext cx="0" cy="0"/>
+          <a:chOff x="0" y="0"/>
+          <a:chExt cx="0" cy="0"/>
+        </a:xfrm>
+      </p:grpSpPr>
+      <p:sp>
+        <p:nvSpPr>
+          <p:cNvPr id="2" name="Slide Image Placeholder 1"/>
+          <p:cNvSpPr>
+            <a:spLocks noGrp="1"/>
+          </p:cNvSpPr>
+          <p:nvPr>
+            <p:ph type="sldImg" idx="2"/>
+          </p:nvPr>
+        </p:nvSpPr>
+        <p:spPr/>
+      </p:sp>
+      <p:sp>
+        <p:nvSpPr>
+          <p:cNvPr id="3" name="Notes Placeholder 2"/>
+          <p:cNvSpPr>
+            <a:spLocks noGrp="1"/>
+          </p:cNvSpPr>
+          <p:nvPr>
+            <p:ph type="body" idx="3" sz="quarter"/>
+          </p:nvPr>
+        </p:nvSpPr>
+        <p:spPr/>
+        <p:txBody>
+          <a:bodyPr/>
+          <a:lstStyle/>
+          <a:p>
+            <a:r>
+              <a:t>Démo: Ouvrir un long fil Outlook. Montrer le bouton Copilot. Cliquer sur Summarize. Montrer le résumé avec les décisions et action items. Insister: «Plus besoin de tout lire!»</a:t>
+            </a:r>
+          </a:p>
+        </p:txBody>
+      </p:sp>
+      <p:sp>
+        <p:nvSpPr>
+          <p:cNvPr id="4" name="Slide Number Placeholder 3"/>
+          <p:cNvSpPr>
+            <a:spLocks noGrp="1"/>
+          </p:cNvSpPr>
+          <p:nvPr>
+            <p:ph type="sldNum" idx="5" sz="quarter"/>
+          </p:nvPr>
+        </p:nvSpPr>
+        <p:spPr/>
+      </p:sp>
+    </p:spTree>
+  </p:cSld>
+  <p:clrMapOvr>
+    <a:masterClrMapping/>
+  </p:clrMapOvr>
+</p:notes>
+</file>
+
+<file path=ppt/notesSlides/notesSlide3.xml><?xml version="1.0" encoding="utf-8"?>
+<p:notes xmlns:a="http://schemas.openxmlformats.org/drawingml/2006/main" xmlns:p="http://schemas.openxmlformats.org/presentationml/2006/main" xmlns:r="http://schemas.openxmlformats.org/officeDocument/2006/relationships">
+  <p:cSld>
+    <p:spTree>
+      <p:nvGrpSpPr>
+        <p:cNvPr id="1" name=""/>
+        <p:cNvGrpSpPr/>
+        <p:nvPr/>
+      </p:nvGrpSpPr>
+      <p:grpSpPr>
+        <a:xfrm>
+          <a:off x="0" y="0"/>
+          <a:ext cx="0" cy="0"/>
+          <a:chOff x="0" y="0"/>
+          <a:chExt cx="0" cy="0"/>
+        </a:xfrm>
+      </p:grpSpPr>
+      <p:sp>
+        <p:nvSpPr>
+          <p:cNvPr id="2" name="Slide Image Placeholder 1"/>
+          <p:cNvSpPr>
+            <a:spLocks noGrp="1"/>
+          </p:cNvSpPr>
+          <p:nvPr>
+            <p:ph type="sldImg" idx="2"/>
+          </p:nvPr>
+        </p:nvSpPr>
+        <p:spPr/>
+      </p:sp>
+      <p:sp>
+        <p:nvSpPr>
+          <p:cNvPr id="3" name="Notes Placeholder 2"/>
+          <p:cNvSpPr>
+            <a:spLocks noGrp="1"/>
+          </p:cNvSpPr>
+          <p:nvPr>
+            <p:ph type="body" idx="3" sz="quarter"/>
+          </p:nvPr>
+        </p:nvSpPr>
+        <p:spPr/>
+        <p:txBody>
+          <a:bodyPr/>
+          <a:lstStyle/>
+          <a:p>
+            <a:r>
+              <a:t>Démo: Répondre à un courriel. Montrer l'icône Copilot dans la fenêtre de réponse. Taper: «Remercie Jean, confirme livraison vendredi». Montrer le résultat. Puis montrer l'ajustement de ton: «Make this more professional».</a:t>
+            </a:r>
+          </a:p>
+        </p:txBody>
+      </p:sp>
+      <p:sp>
+        <p:nvSpPr>
+          <p:cNvPr id="4" name="Slide Number Placeholder 3"/>
+          <p:cNvSpPr>
+            <a:spLocks noGrp="1"/>
+          </p:cNvSpPr>
+          <p:nvPr>
+            <p:ph type="sldNum" idx="5" sz="quarter"/>
+          </p:nvPr>
+        </p:nvSpPr>
+        <p:spPr/>
+      </p:sp>
+    </p:spTree>
+  </p:cSld>
+  <p:clrMapOvr>
+    <a:masterClrMapping/>
+  </p:clrMapOvr>
+</p:notes>
+</file>
+
+<file path=ppt/notesSlides/notesSlide4.xml><?xml version="1.0" encoding="utf-8"?>
+<p:notes xmlns:a="http://schemas.openxmlformats.org/drawingml/2006/main" xmlns:p="http://schemas.openxmlformats.org/presentationml/2006/main" xmlns:r="http://schemas.openxmlformats.org/officeDocument/2006/relationships">
+  <p:cSld>
+    <p:spTree>
+      <p:nvGrpSpPr>
+        <p:cNvPr id="1" name=""/>
+        <p:cNvGrpSpPr/>
+        <p:nvPr/>
+      </p:nvGrpSpPr>
+      <p:grpSpPr>
+        <a:xfrm>
+          <a:off x="0" y="0"/>
+          <a:ext cx="0" cy="0"/>
+          <a:chOff x="0" y="0"/>
+          <a:chExt cx="0" cy="0"/>
+        </a:xfrm>
+      </p:grpSpPr>
+      <p:sp>
+        <p:nvSpPr>
+          <p:cNvPr id="2" name="Slide Image Placeholder 1"/>
+          <p:cNvSpPr>
+            <a:spLocks noGrp="1"/>
+          </p:cNvSpPr>
+          <p:nvPr>
+            <p:ph type="sldImg" idx="2"/>
+          </p:nvPr>
+        </p:nvSpPr>
+        <p:spPr/>
+      </p:sp>
+      <p:sp>
+        <p:nvSpPr>
+          <p:cNvPr id="3" name="Notes Placeholder 2"/>
+          <p:cNvSpPr>
+            <a:spLocks noGrp="1"/>
+          </p:cNvSpPr>
+          <p:nvPr>
+            <p:ph type="body" idx="3" sz="quarter"/>
+          </p:nvPr>
+        </p:nvSpPr>
+        <p:spPr/>
+        <p:txBody>
+          <a:bodyPr/>
+          <a:lstStyle/>
+          <a:p>
+            <a:r>
+              <a:t>Démo: Ouvrir le volet Copilot. Montrer le prompt. Expliquer que c'est utile le lundi matin ou après un congé. Mentionner qu'on peut aussi demander en français.</a:t>
+            </a:r>
+          </a:p>
+        </p:txBody>
+      </p:sp>
+      <p:sp>
+        <p:nvSpPr>
+          <p:cNvPr id="4" name="Slide Number Placeholder 3"/>
+          <p:cNvSpPr>
+            <a:spLocks noGrp="1"/>
+          </p:cNvSpPr>
+          <p:nvPr>
+            <p:ph type="sldNum" idx="5" sz="quarter"/>
+          </p:nvPr>
+        </p:nvSpPr>
+        <p:spPr/>
+      </p:sp>
+    </p:spTree>
+  </p:cSld>
+  <p:clrMapOvr>
+    <a:masterClrMapping/>
+  </p:clrMapOvr>
+</p:notes>
+</file>
+
+<file path=ppt/notesSlides/notesSlide5.xml><?xml version="1.0" encoding="utf-8"?>
+<p:notes xmlns:a="http://schemas.openxmlformats.org/drawingml/2006/main" xmlns:p="http://schemas.openxmlformats.org/presentationml/2006/main" xmlns:r="http://schemas.openxmlformats.org/officeDocument/2006/relationships">
+  <p:cSld>
+    <p:spTree>
+      <p:nvGrpSpPr>
+        <p:cNvPr id="1" name=""/>
+        <p:cNvGrpSpPr/>
+        <p:nvPr/>
+      </p:nvGrpSpPr>
+      <p:grpSpPr>
+        <a:xfrm>
+          <a:off x="0" y="0"/>
+          <a:ext cx="0" cy="0"/>
+          <a:chOff x="0" y="0"/>
+          <a:chExt cx="0" cy="0"/>
+        </a:xfrm>
+      </p:grpSpPr>
+      <p:sp>
+        <p:nvSpPr>
+          <p:cNvPr id="2" name="Slide Image Placeholder 1"/>
+          <p:cNvSpPr>
+            <a:spLocks noGrp="1"/>
+          </p:cNvSpPr>
+          <p:nvPr>
+            <p:ph type="sldImg" idx="2"/>
+          </p:nvPr>
+        </p:nvSpPr>
+        <p:spPr/>
+      </p:sp>
+      <p:sp>
+        <p:nvSpPr>
+          <p:cNvPr id="3" name="Notes Placeholder 2"/>
+          <p:cNvSpPr>
+            <a:spLocks noGrp="1"/>
+          </p:cNvSpPr>
+          <p:nvPr>
+            <p:ph type="body" idx="3" sz="quarter"/>
+          </p:nvPr>
+        </p:nvSpPr>
+        <p:spPr/>
+        <p:txBody>
+          <a:bodyPr/>
+          <a:lstStyle/>
+          <a:p>
+            <a:r>
+              <a:t>Astuce préférée! Les prompts Copilot ne se sauvegardent pas automatiquement. Avec Quick Parts, on les réutilise en un clic. Montrer la démo: créer un Quick Part, l'utiliser dans un nouveau courriel.</a:t>
+            </a:r>
+          </a:p>
+        </p:txBody>
+      </p:sp>
+      <p:sp>
+        <p:nvSpPr>
+          <p:cNvPr id="4" name="Slide Number Placeholder 3"/>
+          <p:cNvSpPr>
+            <a:spLocks noGrp="1"/>
+          </p:cNvSpPr>
+          <p:nvPr>
+            <p:ph type="sldNum" idx="5" sz="quarter"/>
+          </p:nvPr>
+        </p:nvSpPr>
+        <p:spPr/>
+      </p:sp>
+    </p:spTree>
+  </p:cSld>
+  <p:clrMapOvr>
+    <a:masterClrMapping/>
+  </p:clrMapOvr>
+</p:notes>
+</file>
+
+<file path=ppt/notesSlides/notesSlide6.xml><?xml version="1.0" encoding="utf-8"?>
+<p:notes xmlns:a="http://schemas.openxmlformats.org/drawingml/2006/main" xmlns:p="http://schemas.openxmlformats.org/presentationml/2006/main" xmlns:r="http://schemas.openxmlformats.org/officeDocument/2006/relationships">
+  <p:cSld>
+    <p:spTree>
+      <p:nvGrpSpPr>
+        <p:cNvPr id="1" name=""/>
+        <p:cNvGrpSpPr/>
+        <p:nvPr/>
+      </p:nvGrpSpPr>
+      <p:grpSpPr>
+        <a:xfrm>
+          <a:off x="0" y="0"/>
+          <a:ext cx="0" cy="0"/>
+          <a:chOff x="0" y="0"/>
+          <a:chExt cx="0" cy="0"/>
+        </a:xfrm>
+      </p:grpSpPr>
+      <p:sp>
+        <p:nvSpPr>
+          <p:cNvPr id="2" name="Slide Image Placeholder 1"/>
+          <p:cNvSpPr>
+            <a:spLocks noGrp="1"/>
+          </p:cNvSpPr>
+          <p:nvPr>
+            <p:ph type="sldImg" idx="2"/>
+          </p:nvPr>
+        </p:nvSpPr>
+        <p:spPr/>
+      </p:sp>
+      <p:sp>
+        <p:nvSpPr>
+          <p:cNvPr id="3" name="Notes Placeholder 2"/>
+          <p:cNvSpPr>
+            <a:spLocks noGrp="1"/>
+          </p:cNvSpPr>
+          <p:nvPr>
+            <p:ph type="body" idx="3" sz="quarter"/>
+          </p:nvPr>
+        </p:nvSpPr>
+        <p:spPr/>
+        <p:txBody>
+          <a:bodyPr/>
+          <a:lstStyle/>
+          <a:p>
+            <a:r>
+              <a:t>Récapitulation rapide. Encourager à essayer AU MOINS UNE astuce cette semaine. Rappeler le prochain rendez-vous!</a:t>
+            </a:r>
+          </a:p>
+        </p:txBody>
+      </p:sp>
+      <p:sp>
+        <p:nvSpPr>
+          <p:cNvPr id="4" name="Slide Number Placeholder 3"/>
+          <p:cNvSpPr>
+            <a:spLocks noGrp="1"/>
+          </p:cNvSpPr>
+          <p:nvPr>
+            <p:ph type="sldNum" idx="5" sz="quarter"/>
+          </p:nvPr>
+        </p:nvSpPr>
+        <p:spPr/>
+      </p:sp>
+    </p:spTree>
+  </p:cSld>
+  <p:clrMapOvr>
+    <a:masterClrMapping/>
+  </p:clrMapOvr>
+</p:notes>
 </file>
 
 <file path=ppt/slideLayouts/slideLayout1.xml><?xml version="1.0" encoding="utf-8"?>
@@ -3309,14 +4079,85 @@
       </p:sp>
       <p:sp>
         <p:nvSpPr>
-          <p:cNvPr id="4" name="Rectangle 3"/>
+          <p:cNvPr id="4" name="TextBox 3"/>
+          <p:cNvSpPr txBox="1"/>
+          <p:nvPr/>
+        </p:nvSpPr>
+        <p:spPr>
+          <a:xfrm>
+            <a:off x="457200" y="1554480"/>
+            <a:ext cx="10972800" cy="1371600"/>
+          </a:xfrm>
+          <a:prstGeom prst="rect">
+            <a:avLst/>
+          </a:prstGeom>
+          <a:noFill/>
+        </p:spPr>
+        <p:txBody>
+          <a:bodyPr wrap="square">
+            <a:spAutoFit/>
+          </a:bodyPr>
+          <a:lstStyle/>
+          <a:p>
+            <a:pPr>
+              <a:spcAft>
+                <a:spcPts val="400"/>
+              </a:spcAft>
+              <a:defRPr sz="1400">
+                <a:solidFill>
+                  <a:srgbClr val="2B2B2B"/>
+                </a:solidFill>
+                <a:latin typeface="Calibri"/>
+              </a:defRPr>
+            </a:pPr>
+            <a:r>
+              <a:t>• Ouvrir un courriel dans un long fil</a:t>
+            </a:r>
+          </a:p>
+          <a:p>
+            <a:pPr>
+              <a:spcAft>
+                <a:spcPts val="400"/>
+              </a:spcAft>
+              <a:defRPr sz="1400">
+                <a:solidFill>
+                  <a:srgbClr val="2B2B2B"/>
+                </a:solidFill>
+                <a:latin typeface="Calibri"/>
+              </a:defRPr>
+            </a:pPr>
+            <a:r>
+              <a:t>• Cliquer sur l'icône Copilot dans le ruban</a:t>
+            </a:r>
+          </a:p>
+          <a:p>
+            <a:pPr>
+              <a:spcAft>
+                <a:spcPts val="400"/>
+              </a:spcAft>
+              <a:defRPr sz="1400">
+                <a:solidFill>
+                  <a:srgbClr val="2B2B2B"/>
+                </a:solidFill>
+                <a:latin typeface="Calibri"/>
+              </a:defRPr>
+            </a:pPr>
+            <a:r>
+              <a:t>• Choisir «Summarize» ou taper sa propre demande</a:t>
+            </a:r>
+          </a:p>
+        </p:txBody>
+      </p:sp>
+      <p:sp>
+        <p:nvSpPr>
+          <p:cNvPr id="5" name="Rectangle 4"/>
           <p:cNvSpPr/>
           <p:nvPr/>
         </p:nvSpPr>
         <p:spPr>
           <a:xfrm>
-            <a:off x="457200" y="1554480"/>
-            <a:ext cx="3474720" cy="4754880"/>
+            <a:off x="457200" y="3017520"/>
+            <a:ext cx="5212080" cy="3657600"/>
           </a:xfrm>
           <a:prstGeom prst="rect">
             <a:avLst/>
@@ -3354,14 +4195,14 @@
       </p:sp>
       <p:sp>
         <p:nvSpPr>
-          <p:cNvPr id="5" name="TextBox 4"/>
+          <p:cNvPr id="6" name="TextBox 5"/>
           <p:cNvSpPr txBox="1"/>
           <p:nvPr/>
         </p:nvSpPr>
         <p:spPr>
           <a:xfrm>
-            <a:off x="731520" y="1737360"/>
-            <a:ext cx="2926079" cy="457200"/>
+            <a:off x="731520" y="3200400"/>
+            <a:ext cx="4663440" cy="457200"/>
           </a:xfrm>
           <a:prstGeom prst="rect">
             <a:avLst/>
@@ -3377,27 +4218,27 @@
             <a:pPr algn="l">
               <a:defRPr sz="1800" b="1">
                 <a:solidFill>
-                  <a:srgbClr val="0078D4"/>
+                  <a:srgbClr val="10B981"/>
                 </a:solidFill>
                 <a:latin typeface="Calibri"/>
               </a:defRPr>
             </a:pPr>
             <a:r>
-              <a:t>📋 Comment faire?</a:t>
-            </a:r>
-          </a:p>
-        </p:txBody>
-      </p:sp>
-      <p:sp>
-        <p:nvSpPr>
-          <p:cNvPr id="6" name="TextBox 5"/>
+              <a:t>💬 Exemples de prompts</a:t>
+            </a:r>
+          </a:p>
+        </p:txBody>
+      </p:sp>
+      <p:sp>
+        <p:nvSpPr>
+          <p:cNvPr id="7" name="TextBox 6"/>
           <p:cNvSpPr txBox="1"/>
           <p:nvPr/>
         </p:nvSpPr>
         <p:spPr>
           <a:xfrm>
-            <a:off x="731520" y="2194560"/>
-            <a:ext cx="2926079" cy="3840480"/>
+            <a:off x="731520" y="3657600"/>
+            <a:ext cx="4663440" cy="2743200"/>
           </a:xfrm>
           <a:prstGeom prst="rect">
             <a:avLst/>
@@ -3422,7 +4263,7 @@
               </a:defRPr>
             </a:pPr>
             <a:r>
-              <a:t>1. Ouvrir un courriel dans un fil</a:t>
+              <a:t>«Résume ce fil et liste les décisions prises»</a:t>
             </a:r>
           </a:p>
           <a:p>
@@ -3438,7 +4279,7 @@
               </a:defRPr>
             </a:pPr>
             <a:r>
-              <a:t>2. Cliquer sur l'icône Copilot dans le ruban</a:t>
+              <a:t>«Quelles sont les dates de livraison?»</a:t>
             </a:r>
           </a:p>
           <a:p>
@@ -3454,66 +4295,21 @@
               </a:defRPr>
             </a:pPr>
             <a:r>
-              <a:t>3. Choisir «Summarize»</a:t>
-            </a:r>
-          </a:p>
-          <a:p>
-            <a:pPr>
-              <a:spcAft>
-                <a:spcPts val="400"/>
-              </a:spcAft>
-              <a:defRPr sz="1300">
-                <a:solidFill>
-                  <a:srgbClr val="2B2B2B"/>
-                </a:solidFill>
-                <a:latin typeface="Calibri"/>
-              </a:defRPr>
-            </a:pPr>
-          </a:p>
-          <a:p>
-            <a:pPr>
-              <a:spcAft>
-                <a:spcPts val="400"/>
-              </a:spcAft>
-              <a:defRPr sz="1300">
-                <a:solidFill>
-                  <a:srgbClr val="2B2B2B"/>
-                </a:solidFill>
-                <a:latin typeface="Calibri"/>
-              </a:defRPr>
-            </a:pPr>
-            <a:r>
-              <a:t>Ou taper directement votre</a:t>
-            </a:r>
-          </a:p>
-          <a:p>
-            <a:pPr>
-              <a:spcAft>
-                <a:spcPts val="400"/>
-              </a:spcAft>
-              <a:defRPr sz="1300">
-                <a:solidFill>
-                  <a:srgbClr val="2B2B2B"/>
-                </a:solidFill>
-                <a:latin typeface="Calibri"/>
-              </a:defRPr>
-            </a:pPr>
-            <a:r>
-              <a:t>demande en français!</a:t>
-            </a:r>
-          </a:p>
-        </p:txBody>
-      </p:sp>
-      <p:sp>
-        <p:nvSpPr>
-          <p:cNvPr id="7" name="Rectangle 6"/>
+              <a:t>«Extrais les action items avec échéances»</a:t>
+            </a:r>
+          </a:p>
+        </p:txBody>
+      </p:sp>
+      <p:sp>
+        <p:nvSpPr>
+          <p:cNvPr id="8" name="Rectangle 7"/>
           <p:cNvSpPr/>
           <p:nvPr/>
         </p:nvSpPr>
         <p:spPr>
           <a:xfrm>
-            <a:off x="4297680" y="1554480"/>
-            <a:ext cx="3474720" cy="4754880"/>
+            <a:off x="5943600" y="3017520"/>
+            <a:ext cx="5212080" cy="3657600"/>
           </a:xfrm>
           <a:prstGeom prst="rect">
             <a:avLst/>
@@ -3551,14 +4347,14 @@
       </p:sp>
       <p:sp>
         <p:nvSpPr>
-          <p:cNvPr id="8" name="TextBox 7"/>
+          <p:cNvPr id="9" name="TextBox 8"/>
           <p:cNvSpPr txBox="1"/>
           <p:nvPr/>
         </p:nvSpPr>
         <p:spPr>
           <a:xfrm>
-            <a:off x="4572000" y="1737360"/>
-            <a:ext cx="2926079" cy="457200"/>
+            <a:off x="6217920" y="3200400"/>
+            <a:ext cx="4663440" cy="457200"/>
           </a:xfrm>
           <a:prstGeom prst="rect">
             <a:avLst/>
@@ -3574,27 +4370,27 @@
             <a:pPr algn="l">
               <a:defRPr sz="1800" b="1">
                 <a:solidFill>
-                  <a:srgbClr val="10B981"/>
+                  <a:srgbClr val="F59E0B"/>
                 </a:solidFill>
                 <a:latin typeface="Calibri"/>
               </a:defRPr>
             </a:pPr>
             <a:r>
-              <a:t>💬 Exemples de prompts</a:t>
-            </a:r>
-          </a:p>
-        </p:txBody>
-      </p:sp>
-      <p:sp>
-        <p:nvSpPr>
-          <p:cNvPr id="9" name="TextBox 8"/>
+              <a:t>🎯 Qui? Pourquoi?</a:t>
+            </a:r>
+          </a:p>
+        </p:txBody>
+      </p:sp>
+      <p:sp>
+        <p:nvSpPr>
+          <p:cNvPr id="10" name="TextBox 9"/>
           <p:cNvSpPr txBox="1"/>
           <p:nvPr/>
         </p:nvSpPr>
         <p:spPr>
           <a:xfrm>
-            <a:off x="4572000" y="2194560"/>
-            <a:ext cx="2926079" cy="3840480"/>
+            <a:off x="6217920" y="3657600"/>
+            <a:ext cx="4663440" cy="2743200"/>
           </a:xfrm>
           <a:prstGeom prst="rect">
             <a:avLst/>
@@ -3619,7 +4415,7 @@
               </a:defRPr>
             </a:pPr>
             <a:r>
-              <a:t>«Résume ce fil de discussion et</a:t>
+              <a:t>👨‍💼 Gestionnaires: suivre plusieurs projets</a:t>
             </a:r>
           </a:p>
           <a:p>
@@ -3635,7 +4431,7 @@
               </a:defRPr>
             </a:pPr>
             <a:r>
-              <a:t>liste les décisions prises»</a:t>
+              <a:t>👩‍💻 IT: retour de congé → 50 courriels résumés</a:t>
             </a:r>
           </a:p>
           <a:p>
@@ -3650,324 +4446,8 @@
                 <a:latin typeface="Calibri"/>
               </a:defRPr>
             </a:pPr>
-          </a:p>
-          <a:p>
-            <a:pPr>
-              <a:spcAft>
-                <a:spcPts val="400"/>
-              </a:spcAft>
-              <a:defRPr sz="1300">
-                <a:solidFill>
-                  <a:srgbClr val="2B2B2B"/>
-                </a:solidFill>
-                <a:latin typeface="Calibri"/>
-              </a:defRPr>
-            </a:pPr>
-            <a:r>
-              <a:t>«Quelles sont les dates de</a:t>
-            </a:r>
-          </a:p>
-          <a:p>
-            <a:pPr>
-              <a:spcAft>
-                <a:spcPts val="400"/>
-              </a:spcAft>
-              <a:defRPr sz="1300">
-                <a:solidFill>
-                  <a:srgbClr val="2B2B2B"/>
-                </a:solidFill>
-                <a:latin typeface="Calibri"/>
-              </a:defRPr>
-            </a:pPr>
-            <a:r>
-              <a:t>livraison mentionnées?»</a:t>
-            </a:r>
-          </a:p>
-          <a:p>
-            <a:pPr>
-              <a:spcAft>
-                <a:spcPts val="400"/>
-              </a:spcAft>
-              <a:defRPr sz="1300">
-                <a:solidFill>
-                  <a:srgbClr val="2B2B2B"/>
-                </a:solidFill>
-                <a:latin typeface="Calibri"/>
-              </a:defRPr>
-            </a:pPr>
-          </a:p>
-          <a:p>
-            <a:pPr>
-              <a:spcAft>
-                <a:spcPts val="400"/>
-              </a:spcAft>
-              <a:defRPr sz="1300">
-                <a:solidFill>
-                  <a:srgbClr val="2B2B2B"/>
-                </a:solidFill>
-                <a:latin typeface="Calibri"/>
-              </a:defRPr>
-            </a:pPr>
-            <a:r>
-              <a:t>«Extrais les action items avec</a:t>
-            </a:r>
-          </a:p>
-          <a:p>
-            <a:pPr>
-              <a:spcAft>
-                <a:spcPts val="400"/>
-              </a:spcAft>
-              <a:defRPr sz="1300">
-                <a:solidFill>
-                  <a:srgbClr val="2B2B2B"/>
-                </a:solidFill>
-                <a:latin typeface="Calibri"/>
-              </a:defRPr>
-            </a:pPr>
-            <a:r>
-              <a:t>responsables et échéances»</a:t>
-            </a:r>
-          </a:p>
-        </p:txBody>
-      </p:sp>
-      <p:sp>
-        <p:nvSpPr>
-          <p:cNvPr id="10" name="Rectangle 9"/>
-          <p:cNvSpPr/>
-          <p:nvPr/>
-        </p:nvSpPr>
-        <p:spPr>
-          <a:xfrm>
-            <a:off x="8138160" y="1554480"/>
-            <a:ext cx="3474720" cy="4754880"/>
-          </a:xfrm>
-          <a:prstGeom prst="rect">
-            <a:avLst/>
-          </a:prstGeom>
-          <a:solidFill>
-            <a:srgbClr val="FFFFFF"/>
-          </a:solidFill>
-          <a:ln>
-            <a:solidFill>
-              <a:srgbClr val="E0E0E0"/>
-            </a:solidFill>
-          </a:ln>
-        </p:spPr>
-        <p:style>
-          <a:lnRef idx="1">
-            <a:schemeClr val="accent1"/>
-          </a:lnRef>
-          <a:fillRef idx="3">
-            <a:schemeClr val="accent1"/>
-          </a:fillRef>
-          <a:effectRef idx="2">
-            <a:schemeClr val="accent1"/>
-          </a:effectRef>
-          <a:fontRef idx="minor">
-            <a:schemeClr val="lt1"/>
-          </a:fontRef>
-        </p:style>
-        <p:txBody>
-          <a:bodyPr rtlCol="0" anchor="ctr"/>
-          <a:lstStyle/>
-          <a:p>
-            <a:pPr algn="ctr"/>
-          </a:p>
-        </p:txBody>
-      </p:sp>
-      <p:sp>
-        <p:nvSpPr>
-          <p:cNvPr id="11" name="TextBox 10"/>
-          <p:cNvSpPr txBox="1"/>
-          <p:nvPr/>
-        </p:nvSpPr>
-        <p:spPr>
-          <a:xfrm>
-            <a:off x="8412480" y="1737360"/>
-            <a:ext cx="2926079" cy="457200"/>
-          </a:xfrm>
-          <a:prstGeom prst="rect">
-            <a:avLst/>
-          </a:prstGeom>
-          <a:noFill/>
-        </p:spPr>
-        <p:txBody>
-          <a:bodyPr wrap="square">
-            <a:spAutoFit/>
-          </a:bodyPr>
-          <a:lstStyle/>
-          <a:p>
-            <a:pPr algn="l">
-              <a:defRPr sz="1800" b="1">
-                <a:solidFill>
-                  <a:srgbClr val="F59E0B"/>
-                </a:solidFill>
-                <a:latin typeface="Calibri"/>
-              </a:defRPr>
-            </a:pPr>
-            <a:r>
-              <a:t>🎯 Qui? Pourquoi?</a:t>
-            </a:r>
-          </a:p>
-        </p:txBody>
-      </p:sp>
-      <p:sp>
-        <p:nvSpPr>
-          <p:cNvPr id="12" name="TextBox 11"/>
-          <p:cNvSpPr txBox="1"/>
-          <p:nvPr/>
-        </p:nvSpPr>
-        <p:spPr>
-          <a:xfrm>
-            <a:off x="8412480" y="2194560"/>
-            <a:ext cx="2926079" cy="3840480"/>
-          </a:xfrm>
-          <a:prstGeom prst="rect">
-            <a:avLst/>
-          </a:prstGeom>
-          <a:noFill/>
-        </p:spPr>
-        <p:txBody>
-          <a:bodyPr wrap="square">
-            <a:spAutoFit/>
-          </a:bodyPr>
-          <a:lstStyle/>
-          <a:p>
-            <a:pPr>
-              <a:spcAft>
-                <a:spcPts val="400"/>
-              </a:spcAft>
-              <a:defRPr sz="1300">
-                <a:solidFill>
-                  <a:srgbClr val="2B2B2B"/>
-                </a:solidFill>
-                <a:latin typeface="Calibri"/>
-              </a:defRPr>
-            </a:pPr>
-            <a:r>
-              <a:t>👨‍💼 Gestionnaires:</a:t>
-            </a:r>
-          </a:p>
-          <a:p>
-            <a:pPr>
-              <a:spcAft>
-                <a:spcPts val="400"/>
-              </a:spcAft>
-              <a:defRPr sz="1300">
-                <a:solidFill>
-                  <a:srgbClr val="2B2B2B"/>
-                </a:solidFill>
-                <a:latin typeface="Calibri"/>
-              </a:defRPr>
-            </a:pPr>
-            <a:r>
-              <a:t>Suivre 5 projets à la fois</a:t>
-            </a:r>
-          </a:p>
-          <a:p>
-            <a:pPr>
-              <a:spcAft>
-                <a:spcPts val="400"/>
-              </a:spcAft>
-              <a:defRPr sz="1300">
-                <a:solidFill>
-                  <a:srgbClr val="2B2B2B"/>
-                </a:solidFill>
-                <a:latin typeface="Calibri"/>
-              </a:defRPr>
-            </a:pPr>
-          </a:p>
-          <a:p>
-            <a:pPr>
-              <a:spcAft>
-                <a:spcPts val="400"/>
-              </a:spcAft>
-              <a:defRPr sz="1300">
-                <a:solidFill>
-                  <a:srgbClr val="2B2B2B"/>
-                </a:solidFill>
-                <a:latin typeface="Calibri"/>
-              </a:defRPr>
-            </a:pPr>
-            <a:r>
-              <a:t>👩‍💻 IT:</a:t>
-            </a:r>
-          </a:p>
-          <a:p>
-            <a:pPr>
-              <a:spcAft>
-                <a:spcPts val="400"/>
-              </a:spcAft>
-              <a:defRPr sz="1300">
-                <a:solidFill>
-                  <a:srgbClr val="2B2B2B"/>
-                </a:solidFill>
-                <a:latin typeface="Calibri"/>
-              </a:defRPr>
-            </a:pPr>
-            <a:r>
-              <a:t>Retour de congé → résumé</a:t>
-            </a:r>
-          </a:p>
-          <a:p>
-            <a:pPr>
-              <a:spcAft>
-                <a:spcPts val="400"/>
-              </a:spcAft>
-              <a:defRPr sz="1300">
-                <a:solidFill>
-                  <a:srgbClr val="2B2B2B"/>
-                </a:solidFill>
-                <a:latin typeface="Calibri"/>
-              </a:defRPr>
-            </a:pPr>
-            <a:r>
-              <a:t>des 50 courriels en 30 sec</a:t>
-            </a:r>
-          </a:p>
-          <a:p>
-            <a:pPr>
-              <a:spcAft>
-                <a:spcPts val="400"/>
-              </a:spcAft>
-              <a:defRPr sz="1300">
-                <a:solidFill>
-                  <a:srgbClr val="2B2B2B"/>
-                </a:solidFill>
-                <a:latin typeface="Calibri"/>
-              </a:defRPr>
-            </a:pPr>
-          </a:p>
-          <a:p>
-            <a:pPr>
-              <a:spcAft>
-                <a:spcPts val="400"/>
-              </a:spcAft>
-              <a:defRPr sz="1300">
-                <a:solidFill>
-                  <a:srgbClr val="2B2B2B"/>
-                </a:solidFill>
-                <a:latin typeface="Calibri"/>
-              </a:defRPr>
-            </a:pPr>
-            <a:r>
-              <a:t>👤 Non-IT:</a:t>
-            </a:r>
-          </a:p>
-          <a:p>
-            <a:pPr>
-              <a:spcAft>
-                <a:spcPts val="400"/>
-              </a:spcAft>
-              <a:defRPr sz="1300">
-                <a:solidFill>
-                  <a:srgbClr val="2B2B2B"/>
-                </a:solidFill>
-                <a:latin typeface="Calibri"/>
-              </a:defRPr>
-            </a:pPr>
-            <a:r>
-              <a:t>Fils interminables de clients</a:t>
+            <a:r>
+              <a:t>👤 Non-IT: fils clients interminables</a:t>
             </a:r>
           </a:p>
         </p:txBody>
@@ -4065,21 +4545,92 @@
               </a:defRPr>
             </a:pPr>
             <a:r>
-              <a:t>Plus besoin de chercher ses mots — décrivez, Copilot écrit</a:t>
-            </a:r>
-          </a:p>
-        </p:txBody>
-      </p:sp>
-      <p:sp>
-        <p:nvSpPr>
-          <p:cNvPr id="4" name="Rectangle 3"/>
+              <a:t>Décrivez en 5 mots, Copilot écrit le reste</a:t>
+            </a:r>
+          </a:p>
+        </p:txBody>
+      </p:sp>
+      <p:sp>
+        <p:nvSpPr>
+          <p:cNvPr id="4" name="TextBox 3"/>
+          <p:cNvSpPr txBox="1"/>
+          <p:nvPr/>
+        </p:nvSpPr>
+        <p:spPr>
+          <a:xfrm>
+            <a:off x="457200" y="1554480"/>
+            <a:ext cx="10972800" cy="1371600"/>
+          </a:xfrm>
+          <a:prstGeom prst="rect">
+            <a:avLst/>
+          </a:prstGeom>
+          <a:noFill/>
+        </p:spPr>
+        <p:txBody>
+          <a:bodyPr wrap="square">
+            <a:spAutoFit/>
+          </a:bodyPr>
+          <a:lstStyle/>
+          <a:p>
+            <a:pPr>
+              <a:spcAft>
+                <a:spcPts val="400"/>
+              </a:spcAft>
+              <a:defRPr sz="1400">
+                <a:solidFill>
+                  <a:srgbClr val="2B2B2B"/>
+                </a:solidFill>
+                <a:latin typeface="Calibri"/>
+              </a:defRPr>
+            </a:pPr>
+            <a:r>
+              <a:t>• Cliquer Reply → icône Copilot dans la fenêtre</a:t>
+            </a:r>
+          </a:p>
+          <a:p>
+            <a:pPr>
+              <a:spcAft>
+                <a:spcPts val="400"/>
+              </a:spcAft>
+              <a:defRPr sz="1400">
+                <a:solidFill>
+                  <a:srgbClr val="2B2B2B"/>
+                </a:solidFill>
+                <a:latin typeface="Calibri"/>
+              </a:defRPr>
+            </a:pPr>
+            <a:r>
+              <a:t>• Taper ce qu'on veut dire en langage naturel</a:t>
+            </a:r>
+          </a:p>
+          <a:p>
+            <a:pPr>
+              <a:spcAft>
+                <a:spcPts val="400"/>
+              </a:spcAft>
+              <a:defRPr sz="1400">
+                <a:solidFill>
+                  <a:srgbClr val="2B2B2B"/>
+                </a:solidFill>
+                <a:latin typeface="Calibri"/>
+              </a:defRPr>
+            </a:pPr>
+            <a:r>
+              <a:t>• Ajuster le ton: professional, friendly, concise</a:t>
+            </a:r>
+          </a:p>
+        </p:txBody>
+      </p:sp>
+      <p:sp>
+        <p:nvSpPr>
+          <p:cNvPr id="5" name="Rectangle 4"/>
           <p:cNvSpPr/>
           <p:nvPr/>
         </p:nvSpPr>
         <p:spPr>
           <a:xfrm>
-            <a:off x="457200" y="1554480"/>
-            <a:ext cx="5303520" cy="4754880"/>
+            <a:off x="457200" y="3017520"/>
+            <a:ext cx="10698480" cy="3657600"/>
           </a:xfrm>
           <a:prstGeom prst="rect">
             <a:avLst/>
@@ -4117,14 +4668,14 @@
       </p:sp>
       <p:sp>
         <p:nvSpPr>
-          <p:cNvPr id="5" name="TextBox 4"/>
+          <p:cNvPr id="6" name="TextBox 5"/>
           <p:cNvSpPr txBox="1"/>
           <p:nvPr/>
         </p:nvSpPr>
         <p:spPr>
           <a:xfrm>
-            <a:off x="731520" y="1737360"/>
-            <a:ext cx="4754880" cy="457200"/>
+            <a:off x="731520" y="3200400"/>
+            <a:ext cx="10149840" cy="457200"/>
           </a:xfrm>
           <a:prstGeom prst="rect">
             <a:avLst/>
@@ -4140,27 +4691,27 @@
             <a:pPr algn="l">
               <a:defRPr sz="1800" b="1">
                 <a:solidFill>
-                  <a:srgbClr val="0078D4"/>
+                  <a:srgbClr val="10B981"/>
                 </a:solidFill>
                 <a:latin typeface="Calibri"/>
               </a:defRPr>
             </a:pPr>
             <a:r>
-              <a:t>📋 Comment faire?</a:t>
-            </a:r>
-          </a:p>
-        </p:txBody>
-      </p:sp>
-      <p:sp>
-        <p:nvSpPr>
-          <p:cNvPr id="6" name="TextBox 5"/>
+              <a:t>🎨 💡 Ajustement de ton</a:t>
+            </a:r>
+          </a:p>
+        </p:txBody>
+      </p:sp>
+      <p:sp>
+        <p:nvSpPr>
+          <p:cNvPr id="7" name="TextBox 6"/>
           <p:cNvSpPr txBox="1"/>
           <p:nvPr/>
         </p:nvSpPr>
         <p:spPr>
           <a:xfrm>
-            <a:off x="731520" y="2194560"/>
-            <a:ext cx="4754880" cy="3840480"/>
+            <a:off x="731520" y="3657600"/>
+            <a:ext cx="10149840" cy="2743200"/>
           </a:xfrm>
           <a:prstGeom prst="rect">
             <a:avLst/>
@@ -4185,7 +4736,7 @@
               </a:defRPr>
             </a:pPr>
             <a:r>
-              <a:t>1. Cliquez sur «Reply» normalement</a:t>
+              <a:t>«Make this more professional»</a:t>
             </a:r>
           </a:p>
           <a:p>
@@ -4201,7 +4752,7 @@
               </a:defRPr>
             </a:pPr>
             <a:r>
-              <a:t>2. Dans le bas de la fenêtre, cliquez</a:t>
+              <a:t>«Make it friendlier»</a:t>
             </a:r>
           </a:p>
           <a:p>
@@ -4217,7 +4768,7 @@
               </a:defRPr>
             </a:pPr>
             <a:r>
-              <a:t>   sur l'icône Copilot</a:t>
+              <a:t>«Make it more concise»</a:t>
             </a:r>
           </a:p>
           <a:p>
@@ -4232,6 +4783,9 @@
                 <a:latin typeface="Calibri"/>
               </a:defRPr>
             </a:pPr>
+            <a:r>
+              <a:t>«Réécris en ton neutre»</a:t>
+            </a:r>
           </a:p>
           <a:p>
             <a:pPr>
@@ -4246,358 +4800,7 @@
               </a:defRPr>
             </a:pPr>
             <a:r>
-              <a:t>3. Tapez ce que vous voulez dire:</a:t>
-            </a:r>
-          </a:p>
-          <a:p>
-            <a:pPr>
-              <a:spcAft>
-                <a:spcPts val="400"/>
-              </a:spcAft>
-              <a:defRPr sz="1300">
-                <a:solidFill>
-                  <a:srgbClr val="2B2B2B"/>
-                </a:solidFill>
-                <a:latin typeface="Calibri"/>
-              </a:defRPr>
-            </a:pPr>
-            <a:r>
-              <a:t>   «Remercie Jean et confirme que le</a:t>
-            </a:r>
-          </a:p>
-          <a:p>
-            <a:pPr>
-              <a:spcAft>
-                <a:spcPts val="400"/>
-              </a:spcAft>
-              <a:defRPr sz="1300">
-                <a:solidFill>
-                  <a:srgbClr val="2B2B2B"/>
-                </a:solidFill>
-                <a:latin typeface="Calibri"/>
-              </a:defRPr>
-            </a:pPr>
-            <a:r>
-              <a:t>   rapport sera prêt vendredi»</a:t>
-            </a:r>
-          </a:p>
-          <a:p>
-            <a:pPr>
-              <a:spcAft>
-                <a:spcPts val="400"/>
-              </a:spcAft>
-              <a:defRPr sz="1300">
-                <a:solidFill>
-                  <a:srgbClr val="2B2B2B"/>
-                </a:solidFill>
-                <a:latin typeface="Calibri"/>
-              </a:defRPr>
-            </a:pPr>
-          </a:p>
-          <a:p>
-            <a:pPr>
-              <a:spcAft>
-                <a:spcPts val="400"/>
-              </a:spcAft>
-              <a:defRPr sz="1300">
-                <a:solidFill>
-                  <a:srgbClr val="2B2B2B"/>
-                </a:solidFill>
-                <a:latin typeface="Calibri"/>
-              </a:defRPr>
-            </a:pPr>
-            <a:r>
-              <a:t>4. Copilot génère un brouillon</a:t>
-            </a:r>
-          </a:p>
-          <a:p>
-            <a:pPr>
-              <a:spcAft>
-                <a:spcPts val="400"/>
-              </a:spcAft>
-              <a:defRPr sz="1300">
-                <a:solidFill>
-                  <a:srgbClr val="2B2B2B"/>
-                </a:solidFill>
-                <a:latin typeface="Calibri"/>
-              </a:defRPr>
-            </a:pPr>
-            <a:r>
-              <a:t>→ Vous éditez ou envoyez</a:t>
-            </a:r>
-          </a:p>
-        </p:txBody>
-      </p:sp>
-      <p:sp>
-        <p:nvSpPr>
-          <p:cNvPr id="7" name="Rectangle 6"/>
-          <p:cNvSpPr/>
-          <p:nvPr/>
-        </p:nvSpPr>
-        <p:spPr>
-          <a:xfrm>
-            <a:off x="6126480" y="1554480"/>
-            <a:ext cx="5303520" cy="4754880"/>
-          </a:xfrm>
-          <a:prstGeom prst="rect">
-            <a:avLst/>
-          </a:prstGeom>
-          <a:solidFill>
-            <a:srgbClr val="FFFFFF"/>
-          </a:solidFill>
-          <a:ln>
-            <a:solidFill>
-              <a:srgbClr val="E0E0E0"/>
-            </a:solidFill>
-          </a:ln>
-        </p:spPr>
-        <p:style>
-          <a:lnRef idx="1">
-            <a:schemeClr val="accent1"/>
-          </a:lnRef>
-          <a:fillRef idx="3">
-            <a:schemeClr val="accent1"/>
-          </a:fillRef>
-          <a:effectRef idx="2">
-            <a:schemeClr val="accent1"/>
-          </a:effectRef>
-          <a:fontRef idx="minor">
-            <a:schemeClr val="lt1"/>
-          </a:fontRef>
-        </p:style>
-        <p:txBody>
-          <a:bodyPr rtlCol="0" anchor="ctr"/>
-          <a:lstStyle/>
-          <a:p>
-            <a:pPr algn="ctr"/>
-          </a:p>
-        </p:txBody>
-      </p:sp>
-      <p:sp>
-        <p:nvSpPr>
-          <p:cNvPr id="8" name="TextBox 7"/>
-          <p:cNvSpPr txBox="1"/>
-          <p:nvPr/>
-        </p:nvSpPr>
-        <p:spPr>
-          <a:xfrm>
-            <a:off x="6400800" y="1737360"/>
-            <a:ext cx="4754880" cy="457200"/>
-          </a:xfrm>
-          <a:prstGeom prst="rect">
-            <a:avLst/>
-          </a:prstGeom>
-          <a:noFill/>
-        </p:spPr>
-        <p:txBody>
-          <a:bodyPr wrap="square">
-            <a:spAutoFit/>
-          </a:bodyPr>
-          <a:lstStyle/>
-          <a:p>
-            <a:pPr algn="l">
-              <a:defRPr sz="1800" b="1">
-                <a:solidFill>
-                  <a:srgbClr val="10B981"/>
-                </a:solidFill>
-                <a:latin typeface="Calibri"/>
-              </a:defRPr>
-            </a:pPr>
-            <a:r>
-              <a:t>🎨 💡 Ajustement de ton</a:t>
-            </a:r>
-          </a:p>
-        </p:txBody>
-      </p:sp>
-      <p:sp>
-        <p:nvSpPr>
-          <p:cNvPr id="9" name="TextBox 8"/>
-          <p:cNvSpPr txBox="1"/>
-          <p:nvPr/>
-        </p:nvSpPr>
-        <p:spPr>
-          <a:xfrm>
-            <a:off x="6400800" y="2194560"/>
-            <a:ext cx="4754880" cy="3840480"/>
-          </a:xfrm>
-          <a:prstGeom prst="rect">
-            <a:avLst/>
-          </a:prstGeom>
-          <a:noFill/>
-        </p:spPr>
-        <p:txBody>
-          <a:bodyPr wrap="square">
-            <a:spAutoFit/>
-          </a:bodyPr>
-          <a:lstStyle/>
-          <a:p>
-            <a:pPr>
-              <a:spcAft>
-                <a:spcPts val="400"/>
-              </a:spcAft>
-              <a:defRPr sz="1300">
-                <a:solidFill>
-                  <a:srgbClr val="2B2B2B"/>
-                </a:solidFill>
-                <a:latin typeface="Calibri"/>
-              </a:defRPr>
-            </a:pPr>
-            <a:r>
-              <a:t>Après la génération, demandez:</a:t>
-            </a:r>
-          </a:p>
-          <a:p>
-            <a:pPr>
-              <a:spcAft>
-                <a:spcPts val="400"/>
-              </a:spcAft>
-              <a:defRPr sz="1300">
-                <a:solidFill>
-                  <a:srgbClr val="2B2B2B"/>
-                </a:solidFill>
-                <a:latin typeface="Calibri"/>
-              </a:defRPr>
-            </a:pPr>
-          </a:p>
-          <a:p>
-            <a:pPr>
-              <a:spcAft>
-                <a:spcPts val="400"/>
-              </a:spcAft>
-              <a:defRPr sz="1300">
-                <a:solidFill>
-                  <a:srgbClr val="2B2B2B"/>
-                </a:solidFill>
-                <a:latin typeface="Calibri"/>
-              </a:defRPr>
-            </a:pPr>
-            <a:r>
-              <a:t>• «Make this more professional»</a:t>
-            </a:r>
-          </a:p>
-          <a:p>
-            <a:pPr>
-              <a:spcAft>
-                <a:spcPts val="400"/>
-              </a:spcAft>
-              <a:defRPr sz="1300">
-                <a:solidFill>
-                  <a:srgbClr val="2B2B2B"/>
-                </a:solidFill>
-                <a:latin typeface="Calibri"/>
-              </a:defRPr>
-            </a:pPr>
-            <a:r>
-              <a:t>• «Make it friendlier»</a:t>
-            </a:r>
-          </a:p>
-          <a:p>
-            <a:pPr>
-              <a:spcAft>
-                <a:spcPts val="400"/>
-              </a:spcAft>
-              <a:defRPr sz="1300">
-                <a:solidFill>
-                  <a:srgbClr val="2B2B2B"/>
-                </a:solidFill>
-                <a:latin typeface="Calibri"/>
-              </a:defRPr>
-            </a:pPr>
-            <a:r>
-              <a:t>• «Make it more concise»</a:t>
-            </a:r>
-          </a:p>
-          <a:p>
-            <a:pPr>
-              <a:spcAft>
-                <a:spcPts val="400"/>
-              </a:spcAft>
-              <a:defRPr sz="1300">
-                <a:solidFill>
-                  <a:srgbClr val="2B2B2B"/>
-                </a:solidFill>
-                <a:latin typeface="Calibri"/>
-              </a:defRPr>
-            </a:pPr>
-            <a:r>
-              <a:t>• «Réécris en ton neutre»</a:t>
-            </a:r>
-          </a:p>
-          <a:p>
-            <a:pPr>
-              <a:spcAft>
-                <a:spcPts val="400"/>
-              </a:spcAft>
-              <a:defRPr sz="1300">
-                <a:solidFill>
-                  <a:srgbClr val="2B2B2B"/>
-                </a:solidFill>
-                <a:latin typeface="Calibri"/>
-              </a:defRPr>
-            </a:pPr>
-            <a:r>
-              <a:t>• «Version courrier interne»</a:t>
-            </a:r>
-          </a:p>
-          <a:p>
-            <a:pPr>
-              <a:spcAft>
-                <a:spcPts val="400"/>
-              </a:spcAft>
-              <a:defRPr sz="1300">
-                <a:solidFill>
-                  <a:srgbClr val="2B2B2B"/>
-                </a:solidFill>
-                <a:latin typeface="Calibri"/>
-              </a:defRPr>
-            </a:pPr>
-          </a:p>
-          <a:p>
-            <a:pPr>
-              <a:spcAft>
-                <a:spcPts val="400"/>
-              </a:spcAft>
-              <a:defRPr sz="1300">
-                <a:solidFill>
-                  <a:srgbClr val="2B2B2B"/>
-                </a:solidFill>
-                <a:latin typeface="Calibri"/>
-              </a:defRPr>
-            </a:pPr>
-            <a:r>
               <a:t>🎯 Pour tout le monde!</a:t>
-            </a:r>
-          </a:p>
-          <a:p>
-            <a:pPr>
-              <a:spcAft>
-                <a:spcPts val="400"/>
-              </a:spcAft>
-              <a:defRPr sz="1300">
-                <a:solidFill>
-                  <a:srgbClr val="2B2B2B"/>
-                </a:solidFill>
-                <a:latin typeface="Calibri"/>
-              </a:defRPr>
-            </a:pPr>
-            <a:r>
-              <a:t>Surtout ceux qui écrivent</a:t>
-            </a:r>
-          </a:p>
-          <a:p>
-            <a:pPr>
-              <a:spcAft>
-                <a:spcPts val="400"/>
-              </a:spcAft>
-              <a:defRPr sz="1300">
-                <a:solidFill>
-                  <a:srgbClr val="2B2B2B"/>
-                </a:solidFill>
-                <a:latin typeface="Calibri"/>
-              </a:defRPr>
-            </a:pPr>
-            <a:r>
-              <a:t>beaucoup de courriels par jour</a:t>
             </a:r>
           </a:p>
         </p:txBody>
@@ -4695,21 +4898,92 @@
               </a:defRPr>
             </a:pPr>
             <a:r>
-              <a:t>Au lieu de fouiller 50+ courriels, laissez Copilot trier</a:t>
-            </a:r>
-          </a:p>
-        </p:txBody>
-      </p:sp>
-      <p:sp>
-        <p:nvSpPr>
-          <p:cNvPr id="4" name="Rectangle 3"/>
+              <a:t>Laissez Copilot trier vos 50+ courriels non lus</a:t>
+            </a:r>
+          </a:p>
+        </p:txBody>
+      </p:sp>
+      <p:sp>
+        <p:nvSpPr>
+          <p:cNvPr id="4" name="TextBox 3"/>
+          <p:cNvSpPr txBox="1"/>
+          <p:nvPr/>
+        </p:nvSpPr>
+        <p:spPr>
+          <a:xfrm>
+            <a:off x="457200" y="1554480"/>
+            <a:ext cx="10972800" cy="1371600"/>
+          </a:xfrm>
+          <a:prstGeom prst="rect">
+            <a:avLst/>
+          </a:prstGeom>
+          <a:noFill/>
+        </p:spPr>
+        <p:txBody>
+          <a:bodyPr wrap="square">
+            <a:spAutoFit/>
+          </a:bodyPr>
+          <a:lstStyle/>
+          <a:p>
+            <a:pPr>
+              <a:spcAft>
+                <a:spcPts val="400"/>
+              </a:spcAft>
+              <a:defRPr sz="1400">
+                <a:solidFill>
+                  <a:srgbClr val="2B2B2B"/>
+                </a:solidFill>
+                <a:latin typeface="Calibri"/>
+              </a:defRPr>
+            </a:pPr>
+            <a:r>
+              <a:t>• Ouvrir le volet Copilot (icône dans le ruban à droite)</a:t>
+            </a:r>
+          </a:p>
+          <a:p>
+            <a:pPr>
+              <a:spcAft>
+                <a:spcPts val="400"/>
+              </a:spcAft>
+              <a:defRPr sz="1400">
+                <a:solidFill>
+                  <a:srgbClr val="2B2B2B"/>
+                </a:solidFill>
+                <a:latin typeface="Calibri"/>
+              </a:defRPr>
+            </a:pPr>
+            <a:r>
+              <a:t>• Écrire: «Show me my most urgent unread emails from today»</a:t>
+            </a:r>
+          </a:p>
+          <a:p>
+            <a:pPr>
+              <a:spcAft>
+                <a:spcPts val="400"/>
+              </a:spcAft>
+              <a:defRPr sz="1400">
+                <a:solidFill>
+                  <a:srgbClr val="2B2B2B"/>
+                </a:solidFill>
+                <a:latin typeface="Calibri"/>
+              </a:defRPr>
+            </a:pPr>
+            <a:r>
+              <a:t>• Copilot trie et explique pourquoi chaque courriel est prioritaire</a:t>
+            </a:r>
+          </a:p>
+        </p:txBody>
+      </p:sp>
+      <p:sp>
+        <p:nvSpPr>
+          <p:cNvPr id="5" name="Rectangle 4"/>
           <p:cNvSpPr/>
           <p:nvPr/>
         </p:nvSpPr>
         <p:spPr>
           <a:xfrm>
-            <a:off x="457200" y="1554480"/>
-            <a:ext cx="3474720" cy="4754880"/>
+            <a:off x="457200" y="3017520"/>
+            <a:ext cx="5212080" cy="3657600"/>
           </a:xfrm>
           <a:prstGeom prst="rect">
             <a:avLst/>
@@ -4747,14 +5021,14 @@
       </p:sp>
       <p:sp>
         <p:nvSpPr>
-          <p:cNvPr id="5" name="TextBox 4"/>
+          <p:cNvPr id="6" name="TextBox 5"/>
           <p:cNvSpPr txBox="1"/>
           <p:nvPr/>
         </p:nvSpPr>
         <p:spPr>
           <a:xfrm>
-            <a:off x="731520" y="1737360"/>
-            <a:ext cx="2926079" cy="457200"/>
+            <a:off x="731520" y="3200400"/>
+            <a:ext cx="4663440" cy="457200"/>
           </a:xfrm>
           <a:prstGeom prst="rect">
             <a:avLst/>
@@ -4770,27 +5044,27 @@
             <a:pPr algn="l">
               <a:defRPr sz="1800" b="1">
                 <a:solidFill>
-                  <a:srgbClr val="0078D4"/>
+                  <a:srgbClr val="10B981"/>
                 </a:solidFill>
                 <a:latin typeface="Calibri"/>
               </a:defRPr>
             </a:pPr>
             <a:r>
-              <a:t>📋 Comment faire?</a:t>
-            </a:r>
-          </a:p>
-        </p:txBody>
-      </p:sp>
-      <p:sp>
-        <p:nvSpPr>
-          <p:cNvPr id="6" name="TextBox 5"/>
+              <a:t>💬 Variations utiles</a:t>
+            </a:r>
+          </a:p>
+        </p:txBody>
+      </p:sp>
+      <p:sp>
+        <p:nvSpPr>
+          <p:cNvPr id="7" name="TextBox 6"/>
           <p:cNvSpPr txBox="1"/>
           <p:nvPr/>
         </p:nvSpPr>
         <p:spPr>
           <a:xfrm>
-            <a:off x="731520" y="2194560"/>
-            <a:ext cx="2926079" cy="3840480"/>
+            <a:off x="731520" y="3657600"/>
+            <a:ext cx="4663440" cy="2743200"/>
           </a:xfrm>
           <a:prstGeom prst="rect">
             <a:avLst/>
@@ -4815,7 +5089,7 @@
               </a:defRPr>
             </a:pPr>
             <a:r>
-              <a:t>Ouvrez le volet Copilot</a:t>
+              <a:t>«Prioritize my emails this week»</a:t>
             </a:r>
           </a:p>
           <a:p>
@@ -4831,7 +5105,7 @@
               </a:defRPr>
             </a:pPr>
             <a:r>
-              <a:t>(icône dans le ruban à droite)</a:t>
+              <a:t>«Quels courriels nécessitent une action?»</a:t>
             </a:r>
           </a:p>
           <a:p>
@@ -4846,109 +5120,22 @@
                 <a:latin typeface="Calibri"/>
               </a:defRPr>
             </a:pPr>
-          </a:p>
-          <a:p>
-            <a:pPr>
-              <a:spcAft>
-                <a:spcPts val="400"/>
-              </a:spcAft>
-              <a:defRPr sz="1300">
-                <a:solidFill>
-                  <a:srgbClr val="2B2B2B"/>
-                </a:solidFill>
-                <a:latin typeface="Calibri"/>
-              </a:defRPr>
-            </a:pPr>
-            <a:r>
-              <a:t>Puis écrivez:</a:t>
-            </a:r>
-          </a:p>
-          <a:p>
-            <a:pPr>
-              <a:spcAft>
-                <a:spcPts val="400"/>
-              </a:spcAft>
-              <a:defRPr sz="1300">
-                <a:solidFill>
-                  <a:srgbClr val="2B2B2B"/>
-                </a:solidFill>
-                <a:latin typeface="Calibri"/>
-              </a:defRPr>
-            </a:pPr>
-          </a:p>
-          <a:p>
-            <a:pPr>
-              <a:spcAft>
-                <a:spcPts val="400"/>
-              </a:spcAft>
-              <a:defRPr sz="1300">
-                <a:solidFill>
-                  <a:srgbClr val="2B2B2B"/>
-                </a:solidFill>
-                <a:latin typeface="Calibri"/>
-              </a:defRPr>
-            </a:pPr>
-            <a:r>
-              <a:t>«Show me my most urgent</a:t>
-            </a:r>
-          </a:p>
-          <a:p>
-            <a:pPr>
-              <a:spcAft>
-                <a:spcPts val="400"/>
-              </a:spcAft>
-              <a:defRPr sz="1300">
-                <a:solidFill>
-                  <a:srgbClr val="2B2B2B"/>
-                </a:solidFill>
-                <a:latin typeface="Calibri"/>
-              </a:defRPr>
-            </a:pPr>
-            <a:r>
-              <a:t>unread emails from today»</a:t>
-            </a:r>
-          </a:p>
-          <a:p>
-            <a:pPr>
-              <a:spcAft>
-                <a:spcPts val="400"/>
-              </a:spcAft>
-              <a:defRPr sz="1300">
-                <a:solidFill>
-                  <a:srgbClr val="2B2B2B"/>
-                </a:solidFill>
-                <a:latin typeface="Calibri"/>
-              </a:defRPr>
-            </a:pPr>
-          </a:p>
-          <a:p>
-            <a:pPr>
-              <a:spcAft>
-                <a:spcPts val="400"/>
-              </a:spcAft>
-              <a:defRPr sz="1300">
-                <a:solidFill>
-                  <a:srgbClr val="2B2B2B"/>
-                </a:solidFill>
-                <a:latin typeface="Calibri"/>
-              </a:defRPr>
-            </a:pPr>
-            <a:r>
-              <a:t>C'est tout!</a:t>
-            </a:r>
-          </a:p>
-        </p:txBody>
-      </p:sp>
-      <p:sp>
-        <p:nvSpPr>
-          <p:cNvPr id="7" name="Rectangle 6"/>
+            <a:r>
+              <a:t>«Résume les courriels de mon gestionnaire»</a:t>
+            </a:r>
+          </a:p>
+        </p:txBody>
+      </p:sp>
+      <p:sp>
+        <p:nvSpPr>
+          <p:cNvPr id="8" name="Rectangle 7"/>
           <p:cNvSpPr/>
           <p:nvPr/>
         </p:nvSpPr>
         <p:spPr>
           <a:xfrm>
-            <a:off x="4297680" y="1554480"/>
-            <a:ext cx="3474720" cy="4754880"/>
+            <a:off x="5943600" y="3017520"/>
+            <a:ext cx="5212080" cy="3657600"/>
           </a:xfrm>
           <a:prstGeom prst="rect">
             <a:avLst/>
@@ -4986,14 +5173,14 @@
       </p:sp>
       <p:sp>
         <p:nvSpPr>
-          <p:cNvPr id="8" name="TextBox 7"/>
+          <p:cNvPr id="9" name="TextBox 8"/>
           <p:cNvSpPr txBox="1"/>
           <p:nvPr/>
         </p:nvSpPr>
         <p:spPr>
           <a:xfrm>
-            <a:off x="4572000" y="1737360"/>
-            <a:ext cx="2926079" cy="457200"/>
+            <a:off x="6217920" y="3200400"/>
+            <a:ext cx="4663440" cy="457200"/>
           </a:xfrm>
           <a:prstGeom prst="rect">
             <a:avLst/>
@@ -5009,27 +5196,27 @@
             <a:pPr algn="l">
               <a:defRPr sz="1800" b="1">
                 <a:solidFill>
-                  <a:srgbClr val="10B981"/>
+                  <a:srgbClr val="F59E0B"/>
                 </a:solidFill>
                 <a:latin typeface="Calibri"/>
               </a:defRPr>
             </a:pPr>
             <a:r>
-              <a:t>💬 Variations utiles</a:t>
-            </a:r>
-          </a:p>
-        </p:txBody>
-      </p:sp>
-      <p:sp>
-        <p:nvSpPr>
-          <p:cNvPr id="9" name="TextBox 8"/>
+              <a:t>🎯 Scénarios gagnants</a:t>
+            </a:r>
+          </a:p>
+        </p:txBody>
+      </p:sp>
+      <p:sp>
+        <p:nvSpPr>
+          <p:cNvPr id="10" name="TextBox 9"/>
           <p:cNvSpPr txBox="1"/>
           <p:nvPr/>
         </p:nvSpPr>
         <p:spPr>
           <a:xfrm>
-            <a:off x="4572000" y="2194560"/>
-            <a:ext cx="2926079" cy="3840480"/>
+            <a:off x="6217920" y="3657600"/>
+            <a:ext cx="4663440" cy="2743200"/>
           </a:xfrm>
           <a:prstGeom prst="rect">
             <a:avLst/>
@@ -5054,7 +5241,7 @@
               </a:defRPr>
             </a:pPr>
             <a:r>
-              <a:t>«Prioritize my emails this</a:t>
+              <a:t>Lundi matin: 50 courriels, 30 secondes</a:t>
             </a:r>
           </a:p>
           <a:p>
@@ -5070,7 +5257,7 @@
               </a:defRPr>
             </a:pPr>
             <a:r>
-              <a:t>week by importance»</a:t>
+              <a:t>Retour de vacances: tout savoir rapidement</a:t>
             </a:r>
           </a:p>
           <a:p>
@@ -5085,356 +5272,8 @@
                 <a:latin typeface="Calibri"/>
               </a:defRPr>
             </a:pPr>
-          </a:p>
-          <a:p>
-            <a:pPr>
-              <a:spcAft>
-                <a:spcPts val="400"/>
-              </a:spcAft>
-              <a:defRPr sz="1300">
-                <a:solidFill>
-                  <a:srgbClr val="2B2B2B"/>
-                </a:solidFill>
-                <a:latin typeface="Calibri"/>
-              </a:defRPr>
-            </a:pPr>
-            <a:r>
-              <a:t>«Quels courriels nécessitent</a:t>
-            </a:r>
-          </a:p>
-          <a:p>
-            <a:pPr>
-              <a:spcAft>
-                <a:spcPts val="400"/>
-              </a:spcAft>
-              <a:defRPr sz="1300">
-                <a:solidFill>
-                  <a:srgbClr val="2B2B2B"/>
-                </a:solidFill>
-                <a:latin typeface="Calibri"/>
-              </a:defRPr>
-            </a:pPr>
-            <a:r>
-              <a:t>une action de ma part</a:t>
-            </a:r>
-          </a:p>
-          <a:p>
-            <a:pPr>
-              <a:spcAft>
-                <a:spcPts val="400"/>
-              </a:spcAft>
-              <a:defRPr sz="1300">
-                <a:solidFill>
-                  <a:srgbClr val="2B2B2B"/>
-                </a:solidFill>
-                <a:latin typeface="Calibri"/>
-              </a:defRPr>
-            </a:pPr>
-            <a:r>
-              <a:t>demain?»</a:t>
-            </a:r>
-          </a:p>
-          <a:p>
-            <a:pPr>
-              <a:spcAft>
-                <a:spcPts val="400"/>
-              </a:spcAft>
-              <a:defRPr sz="1300">
-                <a:solidFill>
-                  <a:srgbClr val="2B2B2B"/>
-                </a:solidFill>
-                <a:latin typeface="Calibri"/>
-              </a:defRPr>
-            </a:pPr>
-          </a:p>
-          <a:p>
-            <a:pPr>
-              <a:spcAft>
-                <a:spcPts val="400"/>
-              </a:spcAft>
-              <a:defRPr sz="1300">
-                <a:solidFill>
-                  <a:srgbClr val="2B2B2B"/>
-                </a:solidFill>
-                <a:latin typeface="Calibri"/>
-              </a:defRPr>
-            </a:pPr>
-            <a:r>
-              <a:t>«Résume les courriels de</a:t>
-            </a:r>
-          </a:p>
-          <a:p>
-            <a:pPr>
-              <a:spcAft>
-                <a:spcPts val="400"/>
-              </a:spcAft>
-              <a:defRPr sz="1300">
-                <a:solidFill>
-                  <a:srgbClr val="2B2B2B"/>
-                </a:solidFill>
-                <a:latin typeface="Calibri"/>
-              </a:defRPr>
-            </a:pPr>
-            <a:r>
-              <a:t>mon gestionnaire des</a:t>
-            </a:r>
-          </a:p>
-          <a:p>
-            <a:pPr>
-              <a:spcAft>
-                <a:spcPts val="400"/>
-              </a:spcAft>
-              <a:defRPr sz="1300">
-                <a:solidFill>
-                  <a:srgbClr val="2B2B2B"/>
-                </a:solidFill>
-                <a:latin typeface="Calibri"/>
-              </a:defRPr>
-            </a:pPr>
-            <a:r>
-              <a:t>derniers jours»</a:t>
-            </a:r>
-          </a:p>
-        </p:txBody>
-      </p:sp>
-      <p:sp>
-        <p:nvSpPr>
-          <p:cNvPr id="10" name="Rectangle 9"/>
-          <p:cNvSpPr/>
-          <p:nvPr/>
-        </p:nvSpPr>
-        <p:spPr>
-          <a:xfrm>
-            <a:off x="8138160" y="1554480"/>
-            <a:ext cx="3474720" cy="4754880"/>
-          </a:xfrm>
-          <a:prstGeom prst="rect">
-            <a:avLst/>
-          </a:prstGeom>
-          <a:solidFill>
-            <a:srgbClr val="FFFFFF"/>
-          </a:solidFill>
-          <a:ln>
-            <a:solidFill>
-              <a:srgbClr val="E0E0E0"/>
-            </a:solidFill>
-          </a:ln>
-        </p:spPr>
-        <p:style>
-          <a:lnRef idx="1">
-            <a:schemeClr val="accent1"/>
-          </a:lnRef>
-          <a:fillRef idx="3">
-            <a:schemeClr val="accent1"/>
-          </a:fillRef>
-          <a:effectRef idx="2">
-            <a:schemeClr val="accent1"/>
-          </a:effectRef>
-          <a:fontRef idx="minor">
-            <a:schemeClr val="lt1"/>
-          </a:fontRef>
-        </p:style>
-        <p:txBody>
-          <a:bodyPr rtlCol="0" anchor="ctr"/>
-          <a:lstStyle/>
-          <a:p>
-            <a:pPr algn="ctr"/>
-          </a:p>
-        </p:txBody>
-      </p:sp>
-      <p:sp>
-        <p:nvSpPr>
-          <p:cNvPr id="11" name="TextBox 10"/>
-          <p:cNvSpPr txBox="1"/>
-          <p:nvPr/>
-        </p:nvSpPr>
-        <p:spPr>
-          <a:xfrm>
-            <a:off x="8412480" y="1737360"/>
-            <a:ext cx="2926079" cy="457200"/>
-          </a:xfrm>
-          <a:prstGeom prst="rect">
-            <a:avLst/>
-          </a:prstGeom>
-          <a:noFill/>
-        </p:spPr>
-        <p:txBody>
-          <a:bodyPr wrap="square">
-            <a:spAutoFit/>
-          </a:bodyPr>
-          <a:lstStyle/>
-          <a:p>
-            <a:pPr algn="l">
-              <a:defRPr sz="1800" b="1">
-                <a:solidFill>
-                  <a:srgbClr val="F59E0B"/>
-                </a:solidFill>
-                <a:latin typeface="Calibri"/>
-              </a:defRPr>
-            </a:pPr>
-            <a:r>
-              <a:t>🎯 Scénarios gagnants</a:t>
-            </a:r>
-          </a:p>
-        </p:txBody>
-      </p:sp>
-      <p:sp>
-        <p:nvSpPr>
-          <p:cNvPr id="12" name="TextBox 11"/>
-          <p:cNvSpPr txBox="1"/>
-          <p:nvPr/>
-        </p:nvSpPr>
-        <p:spPr>
-          <a:xfrm>
-            <a:off x="8412480" y="2194560"/>
-            <a:ext cx="2926079" cy="3840480"/>
-          </a:xfrm>
-          <a:prstGeom prst="rect">
-            <a:avLst/>
-          </a:prstGeom>
-          <a:noFill/>
-        </p:spPr>
-        <p:txBody>
-          <a:bodyPr wrap="square">
-            <a:spAutoFit/>
-          </a:bodyPr>
-          <a:lstStyle/>
-          <a:p>
-            <a:pPr>
-              <a:spcAft>
-                <a:spcPts val="400"/>
-              </a:spcAft>
-              <a:defRPr sz="1300">
-                <a:solidFill>
-                  <a:srgbClr val="2B2B2B"/>
-                </a:solidFill>
-                <a:latin typeface="Calibri"/>
-              </a:defRPr>
-            </a:pPr>
-            <a:r>
-              <a:t>👨‍💼 Lundi matin: prioriser</a:t>
-            </a:r>
-          </a:p>
-          <a:p>
-            <a:pPr>
-              <a:spcAft>
-                <a:spcPts val="400"/>
-              </a:spcAft>
-              <a:defRPr sz="1300">
-                <a:solidFill>
-                  <a:srgbClr val="2B2B2B"/>
-                </a:solidFill>
-                <a:latin typeface="Calibri"/>
-              </a:defRPr>
-            </a:pPr>
-            <a:r>
-              <a:t>50 courriels du week-end</a:t>
-            </a:r>
-          </a:p>
-          <a:p>
-            <a:pPr>
-              <a:spcAft>
-                <a:spcPts val="400"/>
-              </a:spcAft>
-              <a:defRPr sz="1300">
-                <a:solidFill>
-                  <a:srgbClr val="2B2B2B"/>
-                </a:solidFill>
-                <a:latin typeface="Calibri"/>
-              </a:defRPr>
-            </a:pPr>
-          </a:p>
-          <a:p>
-            <a:pPr>
-              <a:spcAft>
-                <a:spcPts val="400"/>
-              </a:spcAft>
-              <a:defRPr sz="1300">
-                <a:solidFill>
-                  <a:srgbClr val="2B2B2B"/>
-                </a:solidFill>
-                <a:latin typeface="Calibri"/>
-              </a:defRPr>
-            </a:pPr>
-            <a:r>
-              <a:t>👩‍💻 Retour de vacances:</a:t>
-            </a:r>
-          </a:p>
-          <a:p>
-            <a:pPr>
-              <a:spcAft>
-                <a:spcPts val="400"/>
-              </a:spcAft>
-              <a:defRPr sz="1300">
-                <a:solidFill>
-                  <a:srgbClr val="2B2B2B"/>
-                </a:solidFill>
-                <a:latin typeface="Calibri"/>
-              </a:defRPr>
-            </a:pPr>
-            <a:r>
-              <a:t>tout savoir en 2 minutes</a:t>
-            </a:r>
-          </a:p>
-          <a:p>
-            <a:pPr>
-              <a:spcAft>
-                <a:spcPts val="400"/>
-              </a:spcAft>
-              <a:defRPr sz="1300">
-                <a:solidFill>
-                  <a:srgbClr val="2B2B2B"/>
-                </a:solidFill>
-                <a:latin typeface="Calibri"/>
-              </a:defRPr>
-            </a:pPr>
-          </a:p>
-          <a:p>
-            <a:pPr>
-              <a:spcAft>
-                <a:spcPts val="400"/>
-              </a:spcAft>
-              <a:defRPr sz="1300">
-                <a:solidFill>
-                  <a:srgbClr val="2B2B2B"/>
-                </a:solidFill>
-                <a:latin typeface="Calibri"/>
-              </a:defRPr>
-            </a:pPr>
-            <a:r>
-              <a:t>👤 Fin de mois:</a:t>
-            </a:r>
-          </a:p>
-          <a:p>
-            <a:pPr>
-              <a:spcAft>
-                <a:spcPts val="400"/>
-              </a:spcAft>
-              <a:defRPr sz="1300">
-                <a:solidFill>
-                  <a:srgbClr val="2B2B2B"/>
-                </a:solidFill>
-                <a:latin typeface="Calibri"/>
-              </a:defRPr>
-            </a:pPr>
-            <a:r>
-              <a:t>ne rien oublier avant</a:t>
-            </a:r>
-          </a:p>
-          <a:p>
-            <a:pPr>
-              <a:spcAft>
-                <a:spcPts val="400"/>
-              </a:spcAft>
-              <a:defRPr sz="1300">
-                <a:solidFill>
-                  <a:srgbClr val="2B2B2B"/>
-                </a:solidFill>
-                <a:latin typeface="Calibri"/>
-              </a:defRPr>
-            </a:pPr>
-            <a:r>
-              <a:t>la date limite</a:t>
+            <a:r>
+              <a:t>Fin de mois: ne rien oublier</a:t>
             </a:r>
           </a:p>
         </p:txBody>
@@ -5496,7 +5335,7 @@
               </a:defRPr>
             </a:pPr>
             <a:r>
-              <a:t>💾 Bonus — Sauvegarder ses prompts Copilot</a:t>
+              <a:t>💾 Bonus — Sauvegarder ses prompts</a:t>
             </a:r>
           </a:p>
         </p:txBody>
@@ -5510,7 +5349,7 @@
         <p:spPr>
           <a:xfrm>
             <a:off x="457200" y="1188720"/>
-            <a:ext cx="3383280" cy="5029200"/>
+            <a:ext cx="5212080" cy="5029200"/>
           </a:xfrm>
           <a:prstGeom prst="rect">
             <a:avLst/>
@@ -5555,7 +5394,7 @@
         <p:spPr>
           <a:xfrm>
             <a:off x="731520" y="1371600"/>
-            <a:ext cx="2834640" cy="457200"/>
+            <a:ext cx="4663440" cy="457200"/>
           </a:xfrm>
           <a:prstGeom prst="rect">
             <a:avLst/>
@@ -5591,7 +5430,7 @@
         <p:spPr>
           <a:xfrm>
             <a:off x="731520" y="1828800"/>
-            <a:ext cx="2834640" cy="4114800"/>
+            <a:ext cx="4663440" cy="4114800"/>
           </a:xfrm>
           <a:prstGeom prst="rect">
             <a:avLst/>
@@ -5648,7 +5487,7 @@
               </a:defRPr>
             </a:pPr>
             <a:r>
-              <a:t>3. Insertion → Quick Parts →</a:t>
+              <a:t>3. Insertion → Quick Parts → Sauvegarder</a:t>
             </a:r>
           </a:p>
           <a:p>
@@ -5664,7 +5503,7 @@
               </a:defRPr>
             </a:pPr>
             <a:r>
-              <a:t>   Save Selection to Quick Part Gallery</a:t>
+              <a:t>4. Nommez: «[CP] Résumer fil»</a:t>
             </a:r>
           </a:p>
           <a:p>
@@ -5679,9 +5518,6 @@
                 <a:latin typeface="Calibri"/>
               </a:defRPr>
             </a:pPr>
-            <a:r>
-              <a:t>4. Nommez: «[CP] Résumer fil»</a:t>
-            </a:r>
           </a:p>
           <a:p>
             <a:pPr>
@@ -5695,6 +5531,9 @@
                 <a:latin typeface="Calibri"/>
               </a:defRPr>
             </a:pPr>
+            <a:r>
+              <a:t>✅ Pour réutiliser:</a:t>
+            </a:r>
           </a:p>
           <a:p>
             <a:pPr>
@@ -5709,52 +5548,7 @@
               </a:defRPr>
             </a:pPr>
             <a:r>
-              <a:t>✅ Réutiliser:</a:t>
-            </a:r>
-          </a:p>
-          <a:p>
-            <a:pPr>
-              <a:spcAft>
-                <a:spcPts val="400"/>
-              </a:spcAft>
-              <a:defRPr sz="1300">
-                <a:solidFill>
-                  <a:srgbClr val="2B2B2B"/>
-                </a:solidFill>
-                <a:latin typeface="Calibri"/>
-              </a:defRPr>
-            </a:pPr>
-            <a:r>
               <a:t>Insertion → Quick Parts → votre prompt</a:t>
-            </a:r>
-          </a:p>
-          <a:p>
-            <a:pPr>
-              <a:spcAft>
-                <a:spcPts val="400"/>
-              </a:spcAft>
-              <a:defRPr sz="1300">
-                <a:solidFill>
-                  <a:srgbClr val="2B2B2B"/>
-                </a:solidFill>
-                <a:latin typeface="Calibri"/>
-              </a:defRPr>
-            </a:pPr>
-          </a:p>
-          <a:p>
-            <a:pPr>
-              <a:spcAft>
-                <a:spcPts val="400"/>
-              </a:spcAft>
-              <a:defRPr sz="1300">
-                <a:solidFill>
-                  <a:srgbClr val="2B2B2B"/>
-                </a:solidFill>
-                <a:latin typeface="Calibri"/>
-              </a:defRPr>
-            </a:pPr>
-            <a:r>
-              <a:t>💡 Créez-en 3-4 pour vos tâches fréquentes!</a:t>
             </a:r>
           </a:p>
         </p:txBody>
@@ -5767,8 +5561,8 @@
         </p:nvSpPr>
         <p:spPr>
           <a:xfrm>
-            <a:off x="4114800" y="1188720"/>
-            <a:ext cx="3383280" cy="5029200"/>
+            <a:off x="5943600" y="1188720"/>
+            <a:ext cx="5212080" cy="5029200"/>
           </a:xfrm>
           <a:prstGeom prst="rect">
             <a:avLst/>
@@ -5812,8 +5606,8 @@
         </p:nvSpPr>
         <p:spPr>
           <a:xfrm>
-            <a:off x="4389120" y="1371600"/>
-            <a:ext cx="2834640" cy="457200"/>
+            <a:off x="6217920" y="1371600"/>
+            <a:ext cx="4663440" cy="457200"/>
           </a:xfrm>
           <a:prstGeom prst="rect">
             <a:avLst/>
@@ -5835,7 +5629,7 @@
               </a:defRPr>
             </a:pPr>
             <a:r>
-              <a:t>📄 OneNote / Bloc-Notes</a:t>
+              <a:t>📄 OneNote ou Copilot Lab</a:t>
             </a:r>
           </a:p>
         </p:txBody>
@@ -5848,8 +5642,8 @@
         </p:nvSpPr>
         <p:spPr>
           <a:xfrm>
-            <a:off x="4389120" y="1828800"/>
-            <a:ext cx="2834640" cy="4114800"/>
+            <a:off x="6217920" y="1828800"/>
+            <a:ext cx="4663440" cy="4114800"/>
           </a:xfrm>
           <a:prstGeom prst="rect">
             <a:avLst/>
@@ -5874,7 +5668,7 @@
               </a:defRPr>
             </a:pPr>
             <a:r>
-              <a:t>Page partagée «Mes prompts Copilot»</a:t>
+              <a:t>📄 OneNote: page partagée</a:t>
             </a:r>
           </a:p>
           <a:p>
@@ -5890,7 +5684,7 @@
               </a:defRPr>
             </a:pPr>
             <a:r>
-              <a:t>Classez par app: Outlook, Teams, Word...</a:t>
+              <a:t>«Mes prompts Copilot»</a:t>
             </a:r>
           </a:p>
           <a:p>
@@ -5905,114 +5699,7 @@
                 <a:latin typeface="Calibri"/>
               </a:defRPr>
             </a:pPr>
-            <a:r>
-              <a:t>Copier-coller → prompt utilisé en 2 sec</a:t>
-            </a:r>
-          </a:p>
-        </p:txBody>
-      </p:sp>
-      <p:sp>
-        <p:nvSpPr>
-          <p:cNvPr id="9" name="Rectangle 8"/>
-          <p:cNvSpPr/>
-          <p:nvPr/>
-        </p:nvSpPr>
-        <p:spPr>
-          <a:xfrm>
-            <a:off x="7772400" y="1188720"/>
-            <a:ext cx="3383280" cy="5029200"/>
-          </a:xfrm>
-          <a:prstGeom prst="rect">
-            <a:avLst/>
-          </a:prstGeom>
-          <a:solidFill>
-            <a:srgbClr val="FFFFFF"/>
-          </a:solidFill>
-          <a:ln>
-            <a:solidFill>
-              <a:srgbClr val="E0E0E0"/>
-            </a:solidFill>
-          </a:ln>
-        </p:spPr>
-        <p:style>
-          <a:lnRef idx="1">
-            <a:schemeClr val="accent1"/>
-          </a:lnRef>
-          <a:fillRef idx="3">
-            <a:schemeClr val="accent1"/>
-          </a:fillRef>
-          <a:effectRef idx="2">
-            <a:schemeClr val="accent1"/>
-          </a:effectRef>
-          <a:fontRef idx="minor">
-            <a:schemeClr val="lt1"/>
-          </a:fontRef>
-        </p:style>
-        <p:txBody>
-          <a:bodyPr rtlCol="0" anchor="ctr"/>
-          <a:lstStyle/>
-          <a:p>
-            <a:pPr algn="ctr"/>
-          </a:p>
-        </p:txBody>
-      </p:sp>
-      <p:sp>
-        <p:nvSpPr>
-          <p:cNvPr id="10" name="TextBox 9"/>
-          <p:cNvSpPr txBox="1"/>
-          <p:nvPr/>
-        </p:nvSpPr>
-        <p:spPr>
-          <a:xfrm>
-            <a:off x="8046720" y="1371600"/>
-            <a:ext cx="2834640" cy="457200"/>
-          </a:xfrm>
-          <a:prstGeom prst="rect">
-            <a:avLst/>
-          </a:prstGeom>
-          <a:noFill/>
-        </p:spPr>
-        <p:txBody>
-          <a:bodyPr wrap="square">
-            <a:spAutoFit/>
-          </a:bodyPr>
-          <a:lstStyle/>
-          <a:p>
-            <a:pPr algn="l">
-              <a:defRPr sz="1800" b="1">
-                <a:solidFill>
-                  <a:srgbClr val="F59E0B"/>
-                </a:solidFill>
-                <a:latin typeface="Calibri"/>
-              </a:defRPr>
-            </a:pPr>
-            <a:r>
-              <a:t>🏪 Copilot Lab (officiel)</a:t>
-            </a:r>
-          </a:p>
-        </p:txBody>
-      </p:sp>
-      <p:sp>
-        <p:nvSpPr>
-          <p:cNvPr id="11" name="TextBox 10"/>
-          <p:cNvSpPr txBox="1"/>
-          <p:nvPr/>
-        </p:nvSpPr>
-        <p:spPr>
-          <a:xfrm>
-            <a:off x="8046720" y="1828800"/>
-            <a:ext cx="2834640" cy="4114800"/>
-          </a:xfrm>
-          <a:prstGeom prst="rect">
-            <a:avLst/>
-          </a:prstGeom>
-          <a:noFill/>
-        </p:spPr>
-        <p:txBody>
-          <a:bodyPr wrap="square">
-            <a:spAutoFit/>
-          </a:bodyPr>
-          <a:lstStyle/>
+          </a:p>
           <a:p>
             <a:pPr>
               <a:spcAft>
@@ -6026,7 +5713,7 @@
               </a:defRPr>
             </a:pPr>
             <a:r>
-              <a:t>Galerie gratuite de prompts Microsoft</a:t>
+              <a:t>🏪 Copilot Lab:</a:t>
             </a:r>
           </a:p>
           <a:p>
@@ -6058,7 +5745,7 @@
               </a:defRPr>
             </a:pPr>
             <a:r>
-              <a:t>Centaines de prompts prêts à copier</a:t>
+              <a:t>Centaines de prompts officiels</a:t>
             </a:r>
           </a:p>
         </p:txBody>
@@ -6239,10 +5926,6 @@
             <a:r>
               <a:t>Fini les longs fils</a:t>
             </a:r>
-            <a:br/>
-            <a:r>
-              <a:t>de discussion</a:t>
-            </a:r>
           </a:p>
         </p:txBody>
       </p:sp>
@@ -6358,11 +6041,7 @@
               </a:defRPr>
             </a:pPr>
             <a:r>
-              <a:t>Décrire en 5 mots</a:t>
-            </a:r>
-            <a:br/>
-            <a:r>
-              <a:t>Copilot écrit le reste</a:t>
+              <a:t>5 mots → Copilot écrit</a:t>
             </a:r>
           </a:p>
         </p:txBody>
@@ -6479,11 +6158,7 @@
               </a:defRPr>
             </a:pPr>
             <a:r>
-              <a:t>50 courriels triés</a:t>
-            </a:r>
-            <a:br/>
-            <a:r>
-              <a:t>en 30 secondes</a:t>
+              <a:t>50 courriels triés en 30s</a:t>
             </a:r>
           </a:p>
         </p:txBody>
@@ -6564,7 +6239,7 @@
               </a:defRPr>
             </a:pPr>
             <a:r>
-              <a:t>💾 Bonus: Sauvegardez vos prompts avec Quick Parts + OneNote + Copilot Lab</a:t>
+              <a:t>💾 Sauvegardez vos prompts avec Quick Parts!</a:t>
             </a:r>
           </a:p>
         </p:txBody>
@@ -6600,7 +6275,7 @@
               </a:defRPr>
             </a:pPr>
             <a:r>
-              <a:t>La minute Copilot — Rendez-vous la semaine prochaine! 👋</a:t>
+              <a:t>La minute Copilot — À la semaine prochaine! 👋</a:t>
             </a:r>
           </a:p>
         </p:txBody>
@@ -6931,4 +6606,324 @@
   </a:objectDefaults>
   <a:extraClrSchemeLst/>
 </a:theme>
+</file>
+
+<file path=ppt/theme/theme2.xml><?xml version="1.0" encoding="utf-8"?>
+<a:theme xmlns:a="http://schemas.openxmlformats.org/drawingml/2006/main" name="Office Theme">
+  <a:themeElements>
+    <a:clrScheme name="Office">
+      <a:dk1>
+        <a:sysClr val="windowText" lastClr="000000"/>
+      </a:dk1>
+      <a:lt1>
+        <a:sysClr val="window" lastClr="FFFFFF"/>
+      </a:lt1>
+      <a:dk2>
+        <a:srgbClr val="1F497D"/>
+      </a:dk2>
+      <a:lt2>
+        <a:srgbClr val="EEECE1"/>
+      </a:lt2>
+      <a:accent1>
+        <a:srgbClr val="4F81BD"/>
+      </a:accent1>
+      <a:accent2>
+        <a:srgbClr val="C0504D"/>
+      </a:accent2>
+      <a:accent3>
+        <a:srgbClr val="9BBB59"/>
+      </a:accent3>
+      <a:accent4>
+        <a:srgbClr val="8064A2"/>
+      </a:accent4>
+      <a:accent5>
+        <a:srgbClr val="4BACC6"/>
+      </a:accent5>
+      <a:accent6>
+        <a:srgbClr val="F79646"/>
+      </a:accent6>
+      <a:hlink>
+        <a:srgbClr val="0000FF"/>
+      </a:hlink>
+      <a:folHlink>
+        <a:srgbClr val="800080"/>
+      </a:folHlink>
+    </a:clrScheme>
+    <a:fontScheme name="Office">
+      <a:majorFont>
+        <a:latin typeface="Calibri"/>
+        <a:ea typeface=""/>
+        <a:cs typeface=""/>
+        <a:font script="Jpan" typeface="ＭＳ Ｐゴシック"/>
+        <a:font script="Hang" typeface="맑은 고딕"/>
+        <a:font script="Hans" typeface="宋体"/>
+        <a:font script="Hant" typeface="新細明體"/>
+        <a:font script="Arab" typeface="Times New Roman"/>
+        <a:font script="Hebr" typeface="Times New Roman"/>
+        <a:font script="Thai" typeface="Angsana New"/>
+        <a:font script="Ethi" typeface="Nyala"/>
+        <a:font script="Beng" typeface="Vrinda"/>
+        <a:font script="Gujr" typeface="Shruti"/>
+        <a:font script="Khmr" typeface="MoolBoran"/>
+        <a:font script="Knda" typeface="Tunga"/>
+        <a:font script="Guru" typeface="Raavi"/>
+        <a:font script="Cans" typeface="Euphemia"/>
+        <a:font script="Cher" typeface="Plantagenet Cherokee"/>
+        <a:font script="Yiii" typeface="Microsoft Yi Baiti"/>
+        <a:font script="Tibt" typeface="Microsoft Himalaya"/>
+        <a:font script="Thaa" typeface="MV Boli"/>
+        <a:font script="Deva" typeface="Mangal"/>
+        <a:font script="Telu" typeface="Gautami"/>
+        <a:font script="Taml" typeface="Latha"/>
+        <a:font script="Syrc" typeface="Estrangelo Edessa"/>
+        <a:font script="Orya" typeface="Kalinga"/>
+        <a:font script="Mlym" typeface="Kartika"/>
+        <a:font script="Laoo" typeface="DokChampa"/>
+        <a:font script="Sinh" typeface="Iskoola Pota"/>
+        <a:font script="Mong" typeface="Mongolian Baiti"/>
+        <a:font script="Viet" typeface="Times New Roman"/>
+        <a:font script="Uigh" typeface="Microsoft Uighur"/>
+        <a:font script="Geor" typeface="Sylfaen"/>
+      </a:majorFont>
+      <a:minorFont>
+        <a:latin typeface="Calibri"/>
+        <a:ea typeface=""/>
+        <a:cs typeface=""/>
+        <a:font script="Jpan" typeface="ＭＳ Ｐゴシック"/>
+        <a:font script="Hang" typeface="맑은 고딕"/>
+        <a:font script="Hans" typeface="宋体"/>
+        <a:font script="Hant" typeface="新細明體"/>
+        <a:font script="Arab" typeface="Arial"/>
+        <a:font script="Hebr" typeface="Arial"/>
+        <a:font script="Thai" typeface="Cordia New"/>
+        <a:font script="Ethi" typeface="Nyala"/>
+        <a:font script="Beng" typeface="Vrinda"/>
+        <a:font script="Gujr" typeface="Shruti"/>
+        <a:font script="Khmr" typeface="DaunPenh"/>
+        <a:font script="Knda" typeface="Tunga"/>
+        <a:font script="Guru" typeface="Raavi"/>
+        <a:font script="Cans" typeface="Euphemia"/>
+        <a:font script="Cher" typeface="Plantagenet Cherokee"/>
+        <a:font script="Yiii" typeface="Microsoft Yi Baiti"/>
+        <a:font script="Tibt" typeface="Microsoft Himalaya"/>
+        <a:font script="Thaa" typeface="MV Boli"/>
+        <a:font script="Deva" typeface="Mangal"/>
+        <a:font script="Telu" typeface="Gautami"/>
+        <a:font script="Taml" typeface="Latha"/>
+        <a:font script="Syrc" typeface="Estrangelo Edessa"/>
+        <a:font script="Orya" typeface="Kalinga"/>
+        <a:font script="Mlym" typeface="Kartika"/>
+        <a:font script="Laoo" typeface="DokChampa"/>
+        <a:font script="Sinh" typeface="Iskoola Pota"/>
+        <a:font script="Mong" typeface="Mongolian Baiti"/>
+        <a:font script="Viet" typeface="Arial"/>
+        <a:font script="Uigh" typeface="Microsoft Uighur"/>
+        <a:font script="Geor" typeface="Sylfaen"/>
+      </a:minorFont>
+    </a:fontScheme>
+    <a:fmtScheme name="Office">
+      <a:fillStyleLst>
+        <a:solidFill>
+          <a:schemeClr val="phClr"/>
+        </a:solidFill>
+        <a:gradFill rotWithShape="1">
+          <a:gsLst>
+            <a:gs pos="0">
+              <a:schemeClr val="phClr">
+                <a:tint val="50000"/>
+                <a:satMod val="300000"/>
+              </a:schemeClr>
+            </a:gs>
+            <a:gs pos="35000">
+              <a:schemeClr val="phClr">
+                <a:tint val="37000"/>
+                <a:satMod val="300000"/>
+              </a:schemeClr>
+            </a:gs>
+            <a:gs pos="100000">
+              <a:schemeClr val="phClr">
+                <a:tint val="15000"/>
+                <a:satMod val="350000"/>
+              </a:schemeClr>
+            </a:gs>
+          </a:gsLst>
+          <a:lin ang="16200000" scaled="1"/>
+        </a:gradFill>
+        <a:gradFill rotWithShape="1">
+          <a:gsLst>
+            <a:gs pos="0">
+              <a:schemeClr val="phClr">
+                <a:tint val="100000"/>
+                <a:shade val="100000"/>
+                <a:satMod val="130000"/>
+              </a:schemeClr>
+            </a:gs>
+            <a:gs pos="100000">
+              <a:schemeClr val="phClr">
+                <a:tint val="50000"/>
+                <a:shade val="100000"/>
+                <a:satMod val="350000"/>
+              </a:schemeClr>
+            </a:gs>
+          </a:gsLst>
+          <a:lin ang="16200000" scaled="0"/>
+        </a:gradFill>
+      </a:fillStyleLst>
+      <a:lnStyleLst>
+        <a:ln w="9525" cap="flat" cmpd="sng" algn="ctr">
+          <a:solidFill>
+            <a:schemeClr val="phClr">
+              <a:shade val="95000"/>
+              <a:satMod val="105000"/>
+            </a:schemeClr>
+          </a:solidFill>
+          <a:prstDash val="solid"/>
+        </a:ln>
+        <a:ln w="25400" cap="flat" cmpd="sng" algn="ctr">
+          <a:solidFill>
+            <a:schemeClr val="phClr"/>
+          </a:solidFill>
+          <a:prstDash val="solid"/>
+        </a:ln>
+        <a:ln w="38100" cap="flat" cmpd="sng" algn="ctr">
+          <a:solidFill>
+            <a:schemeClr val="phClr"/>
+          </a:solidFill>
+          <a:prstDash val="solid"/>
+        </a:ln>
+      </a:lnStyleLst>
+      <a:effectStyleLst>
+        <a:effectStyle>
+          <a:effectLst>
+            <a:outerShdw blurRad="40000" dist="20000" dir="5400000" rotWithShape="0">
+              <a:srgbClr val="000000">
+                <a:alpha val="38000"/>
+              </a:srgbClr>
+            </a:outerShdw>
+          </a:effectLst>
+        </a:effectStyle>
+        <a:effectStyle>
+          <a:effectLst>
+            <a:outerShdw blurRad="40000" dist="23000" dir="5400000" rotWithShape="0">
+              <a:srgbClr val="000000">
+                <a:alpha val="35000"/>
+              </a:srgbClr>
+            </a:outerShdw>
+          </a:effectLst>
+        </a:effectStyle>
+        <a:effectStyle>
+          <a:effectLst>
+            <a:outerShdw blurRad="40000" dist="23000" dir="5400000" rotWithShape="0">
+              <a:srgbClr val="000000">
+                <a:alpha val="35000"/>
+              </a:srgbClr>
+            </a:outerShdw>
+          </a:effectLst>
+          <a:scene3d>
+            <a:camera prst="orthographicFront">
+              <a:rot lat="0" lon="0" rev="0"/>
+            </a:camera>
+            <a:lightRig rig="threePt" dir="t">
+              <a:rot lat="0" lon="0" rev="1200000"/>
+            </a:lightRig>
+          </a:scene3d>
+          <a:sp3d>
+            <a:bevelT w="63500" h="25400"/>
+          </a:sp3d>
+        </a:effectStyle>
+      </a:effectStyleLst>
+      <a:bgFillStyleLst>
+        <a:solidFill>
+          <a:schemeClr val="phClr"/>
+        </a:solidFill>
+        <a:gradFill rotWithShape="1">
+          <a:gsLst>
+            <a:gs pos="0">
+              <a:schemeClr val="phClr">
+                <a:tint val="40000"/>
+                <a:satMod val="350000"/>
+              </a:schemeClr>
+            </a:gs>
+            <a:gs pos="40000">
+              <a:schemeClr val="phClr">
+                <a:tint val="45000"/>
+                <a:shade val="99000"/>
+                <a:satMod val="350000"/>
+              </a:schemeClr>
+            </a:gs>
+            <a:gs pos="100000">
+              <a:schemeClr val="phClr">
+                <a:shade val="20000"/>
+                <a:satMod val="255000"/>
+              </a:schemeClr>
+            </a:gs>
+          </a:gsLst>
+          <a:path path="circle">
+            <a:fillToRect l="50000" t="-80000" r="50000" b="180000"/>
+          </a:path>
+        </a:gradFill>
+        <a:gradFill rotWithShape="1">
+          <a:gsLst>
+            <a:gs pos="0">
+              <a:schemeClr val="phClr">
+                <a:tint val="80000"/>
+                <a:satMod val="300000"/>
+              </a:schemeClr>
+            </a:gs>
+            <a:gs pos="100000">
+              <a:schemeClr val="phClr">
+                <a:shade val="30000"/>
+                <a:satMod val="200000"/>
+              </a:schemeClr>
+            </a:gs>
+          </a:gsLst>
+          <a:path path="circle">
+            <a:fillToRect l="50000" t="50000" r="50000" b="50000"/>
+          </a:path>
+        </a:gradFill>
+      </a:bgFillStyleLst>
+    </a:fmtScheme>
+  </a:themeElements>
+  <a:objectDefaults>
+    <a:spDef>
+      <a:spPr/>
+      <a:bodyPr/>
+      <a:lstStyle/>
+      <a:style>
+        <a:lnRef idx="1">
+          <a:schemeClr val="accent1"/>
+        </a:lnRef>
+        <a:fillRef idx="3">
+          <a:schemeClr val="accent1"/>
+        </a:fillRef>
+        <a:effectRef idx="2">
+          <a:schemeClr val="accent1"/>
+        </a:effectRef>
+        <a:fontRef idx="minor">
+          <a:schemeClr val="lt1"/>
+        </a:fontRef>
+      </a:style>
+    </a:spDef>
+    <a:lnDef>
+      <a:spPr/>
+      <a:bodyPr/>
+      <a:lstStyle/>
+      <a:style>
+        <a:lnRef idx="2">
+          <a:schemeClr val="accent1"/>
+        </a:lnRef>
+        <a:fillRef idx="0">
+          <a:schemeClr val="accent1"/>
+        </a:fillRef>
+        <a:effectRef idx="1">
+          <a:schemeClr val="accent1"/>
+        </a:effectRef>
+        <a:fontRef idx="minor">
+          <a:schemeClr val="tx1"/>
+        </a:fontRef>
+      </a:style>
+    </a:lnDef>
+  </a:objectDefaults>
+  <a:extraClrSchemeLst/>
+</a:theme>
 </file>
</xml_diff>